<commit_message>
Update contributor guide and skill for the top bar navigation
New pieces are now added to a group in src/catalog.js and open from the top
bar menu (localhost:8000/#<id>), so the configurator guide and the contribute
skill say "page" and "top menu" instead of tabs. The guide slides use fresh
screenshots of the redesigned site.

Co-Authored-By: Claude Opus 5.5 <noreply@anthropic.com>
Claude-Session: https://claude.ai/code/session_01An6R85AtxeKr3ZPoBEkGiP
</commit_message>
<xml_diff>
--- a/docs/contributing-guide.pptx
+++ b/docs/contributing-guide.pptx
@@ -123,7 +123,7 @@
   <p:extLst>
     <p:ext uri="{521415D9-36F7-43E2-AB2F-B90AF26B5E84}">
       <p14:sectionLst xmlns:p14="http://schemas.microsoft.com/office/powerpoint/2010/main">
-        <p14:section name="Introduction" id="{8b03bfb0-9b73-b216-5f47-f97f1252b825}">
+        <p14:section name="Introduction" id="{5fdf0a29-7778-b0e6-5535-ceaff9938cea}">
           <p14:sldIdLst>
             <p14:sldId id="256"/>
             <p14:sldId id="257"/>
@@ -131,21 +131,21 @@
             <p14:sldId id="259"/>
           </p14:sldIdLst>
         </p14:section>
-        <p14:section name="The process" id="{f39dd1c1-9127-70d5-9554-dded323ad2ac}">
+        <p14:section name="The process" id="{a74f4ee0-a2f5-f152-eb35-b97691be64ee}">
           <p14:sldIdLst>
             <p14:sldId id="260"/>
             <p14:sldId id="261"/>
             <p14:sldId id="262"/>
           </p14:sldIdLst>
         </p14:section>
-        <p14:section name="Design" id="{5c399425-2926-a77e-f816-5085aa081d84}">
+        <p14:section name="Design" id="{989c19f3-9953-79a0-71a2-2f9ca80f92dc}">
           <p14:sldIdLst>
             <p14:sldId id="263"/>
             <p14:sldId id="264"/>
             <p14:sldId id="265"/>
           </p14:sldIdLst>
         </p14:section>
-        <p14:section name="Build and send" id="{11f36671-39f7-a24a-8171-0e9ea735c9c8}">
+        <p14:section name="Build and send" id="{2a838541-0485-d6b2-5be1-b3d55819e91a}">
           <p14:sldIdLst>
             <p14:sldId id="266"/>
             <p14:sldId id="267"/>
@@ -155,7 +155,7 @@
             <p14:sldId id="271"/>
           </p14:sldIdLst>
         </p14:section>
-        <p14:section name="Summary" id="{b74ff6d0-da2d-f7ce-037f-28b7524a7b68}">
+        <p14:section name="Summary" id="{64de48a1-fae5-ef04-8a6b-5490b1ff3929}">
           <p14:sldIdLst>
             <p14:sldId id="272"/>
           </p14:sldIdLst>
@@ -1180,7 +1180,7 @@
           <a:p>
             <a:r>
               <a:rPr lang="en-US" dirty="0"/>
-              <a:t>If the piece came from an idea, the pull request closes that idea issue when it is merged, and the card leaves the Ideas board because the piece now has its own tab.</a:t>
+              <a:t>If the piece came from an idea, the pull request closes that idea issue when it is merged, and the card leaves the Ideas board because the piece now has its own page in the top menu.</a:t>
             </a:r>
             <a:endParaRPr lang="en-US" dirty="0"/>
           </a:p>
@@ -1356,7 +1356,7 @@
           <a:p>
             <a:r>
               <a:rPr lang="en-US" dirty="0"/>
-              <a:t>Two configurators exist today. Live at mfprado.github.io/open-source-modular-furniture. Your contribution would add a third tab, or improve one of these.</a:t>
+              <a:t>Two configurators exist today. Live at mfprado.github.io/open-source-modular-furniture. Your contribution would add a new page to the top menu, or improve one of these.</a:t>
             </a:r>
             <a:endParaRPr lang="en-US" dirty="0"/>
           </a:p>
@@ -4873,7 +4873,7 @@
                   <a:schemeClr val="tx1"/>
                 </a:solidFill>
               </a:rPr>
-              <a:t>Read the parts list</a:t>
+              <a:t>Find it in the top menu</a:t>
             </a:r>
             <a:endParaRPr lang="en-US" sz="1400" dirty="0"/>
           </a:p>
@@ -6813,7 +6813,7 @@
                   <a:schemeClr val="accent2"/>
                 </a:solidFill>
               </a:rPr>
-              <a:t>Standard parts you can buy anywhere, snapped together into furniture people size themselves. Each piece is a tab on the site: a configurator.</a:t>
+              <a:t>Standard parts you can buy anywhere, snapped together into furniture people size themselves. Each piece is a page on the site, picked from the top menu: a configurator.</a:t>
             </a:r>
             <a:endParaRPr lang="en-US" sz="1500" dirty="0"/>
           </a:p>
@@ -9780,7 +9780,7 @@
                   <a:schemeClr val="tx1"/>
                 </a:solidFill>
               </a:rPr>
-              <a:t>The Ideas tab lists pieces nobody has designed yet, as proposed, each with an open GitHub issue.</a:t>
+              <a:t>The Ideas page (top bar, right) lists pieces nobody has designed yet, as proposed, each with an open GitHub issue.</a:t>
             </a:r>
             <a:endParaRPr lang="en-US" sz="1400" dirty="0"/>
           </a:p>

</xml_diff>

<commit_message>
Start contributor sessions by asking Claude to clone the repository
Step 3 is now telling Claude "I want to work on this repository ... Clone it and
let's start working there" from a This computer session in Documents. Claude
clones it, works inside the clone in the same session, and the contribute flow
takes over: it asks what they want and starts the site. AGENTS.md says so, for
agents that read it from the fresh clone. Next sessions choose the project
folder and say "let's work on this".

Co-Authored-By: Claude Opus 5.5 <noreply@anthropic.com>
Claude-Session: https://claude.ai/code/session_01An6R85AtxeKr3ZPoBEkGiP
</commit_message>
<xml_diff>
--- a/docs/contributing-guide.pptx
+++ b/docs/contributing-guide.pptx
@@ -128,7 +128,7 @@
   <p:extLst>
     <p:ext uri="{521415D9-36F7-43E2-AB2F-B90AF26B5E84}">
       <p14:sectionLst xmlns:p14="http://schemas.microsoft.com/office/powerpoint/2010/main">
-        <p14:section name="Why" id="{ea2ac870-da6c-b019-8c9a-a0223f988ffb}">
+        <p14:section name="Why" id="{e0a5b01c-7f92-5714-4e0b-71cf403bfd52}">
           <p14:sldIdLst>
             <p14:sldId id="256"/>
             <p14:sldId id="257"/>
@@ -138,7 +138,7 @@
             <p14:sldId id="261"/>
           </p14:sldIdLst>
         </p14:section>
-        <p14:section name="Get started" id="{4676ebc3-c221-ef88-e999-6a8a6d89adf2}">
+        <p14:section name="Get started" id="{a6761f0e-ac6a-1c19-0c27-3818c23e6db5}">
           <p14:sldIdLst>
             <p14:sldId id="262"/>
             <p14:sldId id="263"/>
@@ -150,7 +150,7 @@
             <p14:sldId id="269"/>
           </p14:sldIdLst>
         </p14:section>
-        <p14:section name="Work in rounds" id="{b3d14d97-93b1-a246-17aa-81f6910fb8b9}">
+        <p14:section name="Work in rounds" id="{ffd6f793-004e-f79f-e8f6-e5b86ddd3f2f}">
           <p14:sldIdLst>
             <p14:sldId id="270"/>
             <p14:sldId id="271"/>
@@ -159,13 +159,13 @@
             <p14:sldId id="274"/>
           </p14:sldIdLst>
         </p14:section>
-        <p14:section name="Send it" id="{29880790-9b18-aec9-6e2e-2742c0388a8a}">
+        <p14:section name="Send it" id="{814bbee0-66f3-3416-78f1-b8629e1cf07c}">
           <p14:sldIdLst>
             <p14:sldId id="275"/>
             <p14:sldId id="276"/>
           </p14:sldIdLst>
         </p14:section>
-        <p14:section name="Summary" id="{d398fd29-67d1-e880-ac1c-6589e0ceb1dc}">
+        <p14:section name="Summary" id="{d70ebda4-f930-0ced-984f-0f444947d891}">
           <p14:sldIdLst>
             <p14:sldId id="277"/>
           </p14:sldIdLst>
@@ -750,7 +750,7 @@
           <a:p>
             <a:r>
               <a:rPr lang="en-US" dirty="0"/>
-              <a:t>Illustration. Claude needs Git for this; if it is missing, Claude gives you the one link to install it.</a:t>
+              <a:t>Illustration of the folder picker. Any folder works; Documents is easy to find again.</a:t>
             </a:r>
             <a:endParaRPr lang="en-US" dirty="0"/>
           </a:p>
@@ -838,7 +838,7 @@
           <a:p>
             <a:r>
               <a:rPr lang="en-US" dirty="0"/>
-              <a:t>Illustration of the folder picker. Everything Claude needs (instructions, how to start the site) is inside this folder.</a:t>
+              <a:t>Illustration. "Clone" means download the project. Claude needs Git for it; if it is missing, Claude gives you the one link to install it. The project carries Claude's instructions, so as soon as it is downloaded Claude knows how to guide you.</a:t>
             </a:r>
             <a:endParaRPr lang="en-US" dirty="0"/>
           </a:p>
@@ -926,7 +926,7 @@
           <a:p>
             <a:r>
               <a:rPr lang="en-US" dirty="0"/>
-              <a:t>Simulated conversation; exact wording will vary. The instructions Claude follows live in the project itself (the contribute skill), so every session works the same way.</a:t>
+              <a:t>Simulated conversation; exact wording will vary. Next time, skip step 3: click Choose…, pick the open-source-modular-furniture folder in Documents and say "let's work on this".</a:t>
             </a:r>
             <a:endParaRPr lang="en-US" dirty="0"/>
           </a:p>
@@ -3225,7 +3225,7 @@
                   <a:schemeClr val="tx1"/>
                 </a:solidFill>
               </a:rPr>
-              <a:t>Then pick "This computer"</a:t>
+              <a:t>Step 2: pick "This computer"</a:t>
             </a:r>
             <a:endParaRPr lang="en-US" sz="2400" dirty="0"/>
           </a:p>
@@ -3294,7 +3294,7 @@
                   <a:schemeClr val="bg1"/>
                 </a:solidFill>
               </a:rPr>
-              <a:t>1</a:t>
+              <a:t>2</a:t>
             </a:r>
             <a:endParaRPr lang="en-US" sz="1400" dirty="0"/>
           </a:p>
@@ -3536,7 +3536,7 @@
                   <a:schemeClr val="tx1"/>
                 </a:solidFill>
               </a:rPr>
-              <a:t>First time only: get the project</a:t>
+              <a:t>Then Choose… your Documents</a:t>
             </a:r>
             <a:endParaRPr lang="en-US" sz="2400" dirty="0"/>
           </a:p>
@@ -3582,7 +3582,7 @@
       </p:sp>
       <p:pic>
         <p:nvPicPr>
-          <p:cNvPr id="4" name="First time only: get the project" descr="small/app-first.jpg">    </p:cNvPr>
+          <p:cNvPr id="4" name="Then Choose… your Documents" descr="small/app-folder.jpg">    </p:cNvPr>
           <p:cNvPicPr>
             <a:picLocks noChangeAspect="1"/>
           </p:cNvPicPr>
@@ -3643,7 +3643,7 @@
                   <a:schemeClr val="bg1"/>
                 </a:solidFill>
               </a:rPr>
-              <a:t>1×</a:t>
+              <a:t>2</a:t>
             </a:r>
             <a:endParaRPr lang="en-US" sz="1400" dirty="0"/>
           </a:p>
@@ -3679,7 +3679,7 @@
                   <a:schemeClr val="tx1"/>
                 </a:solidFill>
               </a:rPr>
-              <a:t>Claude downloads it</a:t>
+              <a:t>Pick Documents</a:t>
             </a:r>
             <a:endParaRPr lang="en-US" sz="1400" dirty="0"/>
           </a:p>
@@ -3707,7 +3707,7 @@
                   <a:schemeClr val="accent2"/>
                 </a:solidFill>
               </a:rPr>
-              <a:t>Click Choose…, pick your Documents folder and ask Claude to download the project. Do this once; afterwards the project lives in Documents.</a:t>
+              <a:t>Click Choose… (next to This computer) and pick your Documents folder. Claude will put the project there.</a:t>
             </a:r>
             <a:endParaRPr lang="en-US" sz="1400" dirty="0"/>
           </a:p>
@@ -3815,7 +3815,7 @@
                   <a:schemeClr val="tx1"/>
                 </a:solidFill>
               </a:rPr>
-              <a:t>Step 2: choose the project folder</a:t>
+              <a:t>Step 3: tell Claude the project</a:t>
             </a:r>
             <a:endParaRPr lang="en-US" sz="2400" dirty="0"/>
           </a:p>
@@ -3861,7 +3861,7 @@
       </p:sp>
       <p:pic>
         <p:nvPicPr>
-          <p:cNvPr id="4" name="Step 2: choose the project folder" descr="small/app-folder.jpg">    </p:cNvPr>
+          <p:cNvPr id="4" name="Step 3: tell Claude the project" descr="small/app-first.jpg">    </p:cNvPr>
           <p:cNvPicPr>
             <a:picLocks noChangeAspect="1"/>
           </p:cNvPicPr>
@@ -3922,7 +3922,7 @@
                   <a:schemeClr val="bg1"/>
                 </a:solidFill>
               </a:rPr>
-              <a:t>2</a:t>
+              <a:t>3</a:t>
             </a:r>
             <a:endParaRPr lang="en-US" sz="1400" dirty="0"/>
           </a:p>
@@ -3958,7 +3958,7 @@
                   <a:schemeClr val="tx1"/>
                 </a:solidFill>
               </a:rPr>
-              <a:t>Pick the folder</a:t>
+              <a:t>Paste this</a:t>
             </a:r>
             <a:endParaRPr lang="en-US" sz="1400" dirty="0"/>
           </a:p>
@@ -3986,7 +3986,7 @@
                   <a:schemeClr val="accent2"/>
                 </a:solidFill>
               </a:rPr>
-              <a:t>Click Choose… (next to This computer) and pick open-source-modular-furniture in your Documents. Do this at the start of every session.</a:t>
+              <a:t>"I want to work on this repository https://github.com/mfprado/open-source-modular-furniture. Clone it and let's start working there."</a:t>
             </a:r>
             <a:endParaRPr lang="en-US" sz="1400" dirty="0"/>
           </a:p>
@@ -4094,7 +4094,7 @@
                   <a:schemeClr val="tx1"/>
                 </a:solidFill>
               </a:rPr>
-              <a:t>Step 3: say "let's work on this"</a:t>
+              <a:t>Step 4: Claude takes it from there</a:t>
             </a:r>
             <a:endParaRPr lang="en-US" sz="2400" dirty="0"/>
           </a:p>
@@ -4140,7 +4140,7 @@
       </p:sp>
       <p:pic>
         <p:nvPicPr>
-          <p:cNvPr id="4" name="Simulated first conversation" descr="small/sim-start.jpg">    </p:cNvPr>
+          <p:cNvPr id="4" name="Simulated start of the work" descr="small/sim-start.jpg">    </p:cNvPr>
           <p:cNvPicPr>
             <a:picLocks noChangeAspect="1"/>
           </p:cNvPicPr>
@@ -4155,7 +4155,7 @@
         <p:spPr>
           <a:xfrm>
             <a:off x="457200" y="1051560"/>
-            <a:ext cx="5394960" cy="3117516"/>
+            <a:ext cx="5394960" cy="2069353"/>
           </a:xfrm>
           <a:prstGeom prst="rect">
             <a:avLst/>
@@ -8456,7 +8456,7 @@
                   <a:schemeClr val="accent4"/>
                 </a:solidFill>
               </a:rPr>
-              <a:t>Claude app → Code → This computer → Choose… open-source-modular-furniture, then:</a:t>
+              <a:t>Claude app → Code → This computer → Choose… (Documents the first time, then the project folder):</a:t>
             </a:r>
             <a:endParaRPr lang="en-US" sz="1600" dirty="0"/>
           </a:p>
@@ -8470,12 +8470,12 @@
         </p:nvSpPr>
         <p:spPr>
           <a:xfrm>
-            <a:off x="5394960" y="1097280"/>
-            <a:ext cx="3383280" cy="777240"/>
+            <a:off x="5394960" y="822960"/>
+            <a:ext cx="3383280" cy="1005840"/>
           </a:xfrm>
           <a:prstGeom prst="roundRect">
             <a:avLst>
-              <a:gd name="adj" fmla="val 9412"/>
+              <a:gd name="adj" fmla="val 7273"/>
             </a:avLst>
           </a:prstGeom>
           <a:solidFill>
@@ -8497,8 +8497,8 @@
         </p:nvSpPr>
         <p:spPr>
           <a:xfrm>
-            <a:off x="5577840" y="1097280"/>
-            <a:ext cx="3017520" cy="777240"/>
+            <a:off x="5577840" y="822960"/>
+            <a:ext cx="3017520" cy="1005840"/>
           </a:xfrm>
           <a:prstGeom prst="rect">
             <a:avLst/>
@@ -8514,7 +8514,7 @@
               <a:buNone/>
             </a:pPr>
             <a:r>
-              <a:rPr lang="en-US" sz="1400" dirty="0">
+              <a:rPr lang="en-US" sz="1200" dirty="0">
                 <a:solidFill>
                   <a:schemeClr val="bg1"/>
                 </a:solidFill>
@@ -8522,9 +8522,9 @@
                 <a:ea typeface="Courier New" pitchFamily="34" charset="-122"/>
                 <a:cs typeface="Courier New" pitchFamily="34" charset="-120"/>
               </a:rPr>
-              <a:t>"let's work on this"</a:t>
-            </a:r>
-            <a:endParaRPr lang="en-US" sz="1400" dirty="0"/>
+              <a:t>"I want to work on github.com/mfprado/open-source-modular-furniture. Clone it and let's start"</a:t>
+            </a:r>
+            <a:endParaRPr lang="en-US" sz="1200" dirty="0"/>
           </a:p>
         </p:txBody>
       </p:sp>
@@ -8536,12 +8536,12 @@
         </p:nvSpPr>
         <p:spPr>
           <a:xfrm>
-            <a:off x="5394960" y="2103120"/>
-            <a:ext cx="3383280" cy="777240"/>
+            <a:off x="5394960" y="2011680"/>
+            <a:ext cx="3383280" cy="1005840"/>
           </a:xfrm>
           <a:prstGeom prst="roundRect">
             <a:avLst>
-              <a:gd name="adj" fmla="val 9412"/>
+              <a:gd name="adj" fmla="val 7273"/>
             </a:avLst>
           </a:prstGeom>
           <a:solidFill>
@@ -8563,8 +8563,8 @@
         </p:nvSpPr>
         <p:spPr>
           <a:xfrm>
-            <a:off x="5577840" y="2103120"/>
-            <a:ext cx="3017520" cy="777240"/>
+            <a:off x="5577840" y="2011680"/>
+            <a:ext cx="3017520" cy="1005840"/>
           </a:xfrm>
           <a:prstGeom prst="rect">
             <a:avLst/>
@@ -8580,7 +8580,7 @@
               <a:buNone/>
             </a:pPr>
             <a:r>
-              <a:rPr lang="en-US" sz="1400" dirty="0">
+              <a:rPr lang="en-US" sz="1200" dirty="0">
                 <a:solidFill>
                   <a:schemeClr val="bg1"/>
                 </a:solidFill>
@@ -8588,9 +8588,9 @@
                 <a:ea typeface="Courier New" pitchFamily="34" charset="-122"/>
                 <a:cs typeface="Courier New" pitchFamily="34" charset="-120"/>
               </a:rPr>
-              <a:t>"I'm happy, let's send it"</a:t>
-            </a:r>
-            <a:endParaRPr lang="en-US" sz="1400" dirty="0"/>
+              <a:t>"let's work on this" (next times)</a:t>
+            </a:r>
+            <a:endParaRPr lang="en-US" sz="1200" dirty="0"/>
           </a:p>
         </p:txBody>
       </p:sp>
@@ -8602,12 +8602,12 @@
         </p:nvSpPr>
         <p:spPr>
           <a:xfrm>
-            <a:off x="5394960" y="3108960"/>
-            <a:ext cx="3383280" cy="777240"/>
+            <a:off x="5394960" y="3200400"/>
+            <a:ext cx="3383280" cy="1005840"/>
           </a:xfrm>
           <a:prstGeom prst="roundRect">
             <a:avLst>
-              <a:gd name="adj" fmla="val 9412"/>
+              <a:gd name="adj" fmla="val 7273"/>
             </a:avLst>
           </a:prstGeom>
           <a:solidFill>
@@ -8629,8 +8629,8 @@
         </p:nvSpPr>
         <p:spPr>
           <a:xfrm>
-            <a:off x="5577840" y="3108960"/>
-            <a:ext cx="3017520" cy="777240"/>
+            <a:off x="5577840" y="3200400"/>
+            <a:ext cx="3017520" cy="1005840"/>
           </a:xfrm>
           <a:prstGeom prst="rect">
             <a:avLst/>
@@ -8646,7 +8646,7 @@
               <a:buNone/>
             </a:pPr>
             <a:r>
-              <a:rPr lang="en-US" sz="1400" dirty="0">
+              <a:rPr lang="en-US" sz="1200" dirty="0">
                 <a:solidFill>
                   <a:schemeClr val="bg1"/>
                 </a:solidFill>
@@ -8654,9 +8654,9 @@
                 <a:ea typeface="Courier New" pitchFamily="34" charset="-122"/>
                 <a:cs typeface="Courier New" pitchFamily="34" charset="-120"/>
               </a:rPr>
-              <a:t>"let's work on the review comments"</a:t>
-            </a:r>
-            <a:endParaRPr lang="en-US" sz="1400" dirty="0"/>
+              <a:t>"I'm happy, let's send it"</a:t>
+            </a:r>
+            <a:endParaRPr lang="en-US" sz="1200" dirty="0"/>
           </a:p>
         </p:txBody>
       </p:sp>

</xml_diff>

<commit_message>
Update contributor guide deck: new sidebar screenshots, guided checks, approved reviewers wording
Redraw steps 0 and 1 with the new sidebar and Code toggle, swap in a real
example on Before sending and say Claude guides every check, drop the Lego
and You design slides, and say approved reviewers instead of owner.

Co-Authored-By: Claude Sonnet 5.5 <noreply@anthropic.com>
</commit_message>
<xml_diff>
--- a/docs/contributing-guide.pptx
+++ b/docs/contributing-guide.pptx
@@ -6,9 +6,7 @@
   </p:sldMasterIdLst>
   <p:sldIdLst>
     <p:sldId id="256" r:id="rId2"/>
-    <p:sldId id="257" r:id="rId3"/>
     <p:sldId id="258" r:id="rId4"/>
-    <p:sldId id="259" r:id="rId5"/>
     <p:sldId id="260" r:id="rId6"/>
     <p:sldId id="261" r:id="rId7"/>
     <p:sldId id="262" r:id="rId8"/>
@@ -1364,7 +1362,7 @@
           <a:p>
             <a:r>
               <a:rPr lang="en-US" dirty="0"/>
-              <a:t>Claude reads this list out one item at a time and waits for your answer.</a:t>
+              <a:t>Claude is prepared to guide you through all of these checks: it reads the list out one item at a time and waits for your answer.</a:t>
             </a:r>
             <a:endParaRPr lang="en-US" dirty="0"/>
           </a:p>
@@ -1494,94 +1492,6 @@
 </p:notes>
 </file>
 
-<file path=ppt/notesSlides/notesSlide2.xml><?xml version="1.0" encoding="utf-8"?>
-<p:notes xmlns:a="http://schemas.openxmlformats.org/drawingml/2006/main" xmlns:r="http://schemas.openxmlformats.org/officeDocument/2006/relationships" xmlns:p="http://schemas.openxmlformats.org/presentationml/2006/main">
-  <p:cSld>
-    <p:spTree>
-      <p:nvGrpSpPr>
-        <p:cNvPr id="1" name=""/>
-        <p:cNvGrpSpPr/>
-        <p:nvPr/>
-      </p:nvGrpSpPr>
-      <p:grpSpPr>
-        <a:xfrm>
-          <a:off x="0" y="0"/>
-          <a:ext cx="0" cy="0"/>
-          <a:chOff x="0" y="0"/>
-          <a:chExt cx="0" cy="0"/>
-        </a:xfrm>
-      </p:grpSpPr>
-      <p:sp>
-        <p:nvSpPr>
-          <p:cNvPr id="2" name="Slide Image Placeholder 1"/>
-          <p:cNvSpPr>
-            <a:spLocks noGrp="1" noRot="1" noChangeAspect="1"/>
-          </p:cNvSpPr>
-          <p:nvPr>
-            <p:ph type="sldImg"/>
-          </p:nvPr>
-        </p:nvSpPr>
-        <p:spPr/>
-      </p:sp>
-      <p:sp>
-        <p:nvSpPr>
-          <p:cNvPr id="3" name="Notes Placeholder 2"/>
-          <p:cNvSpPr>
-            <a:spLocks noGrp="1"/>
-          </p:cNvSpPr>
-          <p:nvPr>
-            <p:ph type="body" idx="1"/>
-          </p:nvPr>
-        </p:nvSpPr>
-        <p:spPr/>
-        <p:txBody>
-          <a:bodyPr/>
-          <a:lstStyle/>
-          <a:p>
-            <a:r>
-              <a:rPr lang="en-US" dirty="0"/>
-              <a:t>Live at mfprado.github.io/open-source-modular-furniture. A contribution adds a new page to the top menu, or improves one of these.</a:t>
-            </a:r>
-            <a:endParaRPr lang="en-US" dirty="0"/>
-          </a:p>
-        </p:txBody>
-      </p:sp>
-      <p:sp>
-        <p:nvSpPr>
-          <p:cNvPr id="4" name="Slide Number Placeholder 3"/>
-          <p:cNvSpPr>
-            <a:spLocks noGrp="1"/>
-          </p:cNvSpPr>
-          <p:nvPr>
-            <p:ph type="sldNum" sz="quarter" idx="10"/>
-          </p:nvPr>
-        </p:nvSpPr>
-        <p:spPr/>
-        <p:txBody>
-          <a:bodyPr/>
-          <a:lstStyle/>
-          <a:p>
-            <a:fld id="{F7021451-1387-4CA6-816F-3879F97B5CBC}" type="slidenum">
-              <a:rPr lang="en-US"/>
-              <a:t>2</a:t>
-            </a:fld>
-            <a:endParaRPr lang="en-US"/>
-          </a:p>
-        </p:txBody>
-      </p:sp>
-    </p:spTree>
-    <p:extLst>
-      <p:ext uri="{BB962C8B-B14F-4D97-AF65-F5344CB8AC3E}">
-        <p14:creationId xmlns:p14="http://schemas.microsoft.com/office/powerpoint/2010/main" val="1024086991"/>
-      </p:ext>
-    </p:extLst>
-  </p:cSld>
-  <p:clrMapOvr>
-    <a:masterClrMapping/>
-  </p:clrMapOvr>
-</p:notes>
-</file>
-
 <file path=ppt/notesSlides/notesSlide20.xml><?xml version="1.0" encoding="utf-8"?>
 <p:notes xmlns:a="http://schemas.openxmlformats.org/drawingml/2006/main" xmlns:r="http://schemas.openxmlformats.org/officeDocument/2006/relationships" xmlns:p="http://schemas.openxmlformats.org/presentationml/2006/main">
   <p:cSld>
@@ -1628,7 +1538,7 @@
           <a:p>
             <a:r>
               <a:rPr lang="en-US" dirty="0"/>
-              <a:t>Real pull request 10 as the owner sees it on GitHub: what it adds, the idea it closes (#4), the design brief, parts and sources. Merging it closes the idea issue, and the card leaves the Ideas board because the piece now has its own page.</a:t>
+              <a:t>Real pull request 10 as a reviewer sees it on GitHub: what it adds, the idea it closes (#4), the design brief, parts and sources. Merging it closes the idea issue, and the card leaves the Ideas board because the piece now has its own page.</a:t>
             </a:r>
             <a:endParaRPr lang="en-US" dirty="0"/>
           </a:p>
@@ -1804,7 +1714,7 @@
           <a:p>
             <a:r>
               <a:rPr lang="en-US" dirty="0"/>
-              <a:t>The whole process is a loop: see, try, improve by talking, and only when you are happy is the change sent to the owner.</a:t>
+              <a:t>The whole process is a loop: see, try, improve by talking, and only when you are happy is the change sent to the approved reviewers.</a:t>
             </a:r>
             <a:endParaRPr lang="en-US" dirty="0"/>
           </a:p>
@@ -1828,94 +1738,6 @@
             <a:fld id="{F7021451-1387-4CA6-816F-3879F97B5CBC}" type="slidenum">
               <a:rPr lang="en-US"/>
               <a:t>3</a:t>
-            </a:fld>
-            <a:endParaRPr lang="en-US"/>
-          </a:p>
-        </p:txBody>
-      </p:sp>
-    </p:spTree>
-    <p:extLst>
-      <p:ext uri="{BB962C8B-B14F-4D97-AF65-F5344CB8AC3E}">
-        <p14:creationId xmlns:p14="http://schemas.microsoft.com/office/powerpoint/2010/main" val="1024086991"/>
-      </p:ext>
-    </p:extLst>
-  </p:cSld>
-  <p:clrMapOvr>
-    <a:masterClrMapping/>
-  </p:clrMapOvr>
-</p:notes>
-</file>
-
-<file path=ppt/notesSlides/notesSlide4.xml><?xml version="1.0" encoding="utf-8"?>
-<p:notes xmlns:a="http://schemas.openxmlformats.org/drawingml/2006/main" xmlns:r="http://schemas.openxmlformats.org/officeDocument/2006/relationships" xmlns:p="http://schemas.openxmlformats.org/presentationml/2006/main">
-  <p:cSld>
-    <p:spTree>
-      <p:nvGrpSpPr>
-        <p:cNvPr id="1" name=""/>
-        <p:cNvGrpSpPr/>
-        <p:nvPr/>
-      </p:nvGrpSpPr>
-      <p:grpSpPr>
-        <a:xfrm>
-          <a:off x="0" y="0"/>
-          <a:ext cx="0" cy="0"/>
-          <a:chOff x="0" y="0"/>
-          <a:chExt cx="0" cy="0"/>
-        </a:xfrm>
-      </p:grpSpPr>
-      <p:sp>
-        <p:nvSpPr>
-          <p:cNvPr id="2" name="Slide Image Placeholder 1"/>
-          <p:cNvSpPr>
-            <a:spLocks noGrp="1" noRot="1" noChangeAspect="1"/>
-          </p:cNvSpPr>
-          <p:nvPr>
-            <p:ph type="sldImg"/>
-          </p:nvPr>
-        </p:nvSpPr>
-        <p:spPr/>
-      </p:sp>
-      <p:sp>
-        <p:nvSpPr>
-          <p:cNvPr id="3" name="Notes Placeholder 2"/>
-          <p:cNvSpPr>
-            <a:spLocks noGrp="1"/>
-          </p:cNvSpPr>
-          <p:nvPr>
-            <p:ph type="body" idx="1"/>
-          </p:nvPr>
-        </p:nvSpPr>
-        <p:spPr/>
-        <p:txBody>
-          <a:bodyPr/>
-          <a:lstStyle/>
-          <a:p>
-            <a:r>
-              <a:rPr lang="en-US" dirty="0"/>
-              <a:t>No terminal, no code editor. Everything happens in a chat in the Claude desktop app.</a:t>
-            </a:r>
-            <a:endParaRPr lang="en-US" dirty="0"/>
-          </a:p>
-        </p:txBody>
-      </p:sp>
-      <p:sp>
-        <p:nvSpPr>
-          <p:cNvPr id="4" name="Slide Number Placeholder 3"/>
-          <p:cNvSpPr>
-            <a:spLocks noGrp="1"/>
-          </p:cNvSpPr>
-          <p:nvPr>
-            <p:ph type="sldNum" sz="quarter" idx="10"/>
-          </p:nvPr>
-        </p:nvSpPr>
-        <p:spPr/>
-        <p:txBody>
-          <a:bodyPr/>
-          <a:lstStyle/>
-          <a:p>
-            <a:fld id="{F7021451-1387-4CA6-816F-3879F97B5CBC}" type="slidenum">
-              <a:rPr lang="en-US"/>
-              <a:t>4</a:t>
             </a:fld>
             <a:endParaRPr lang="en-US"/>
           </a:p>
@@ -4219,7 +4041,7 @@
                   <a:schemeClr val="accent2"/>
                 </a:solidFill>
               </a:rPr>
-              <a:t>Production: everyone sees it. It only changes after the owner approves.</a:t>
+              <a:t>Production: everyone sees it. It only changes after approved reviewers approve it.</a:t>
             </a:r>
             <a:endParaRPr lang="en-US" sz="1300" dirty="0"/>
           </a:p>
@@ -6459,6 +6281,20 @@
                   <a:schemeClr val="tx1"/>
                 </a:solidFill>
               </a:rPr>
+              <a:t>Claude is prepared to guide you through every check.</a:t>
+            </a:r>
+            <a:endParaRPr lang="en-US" sz="1300" dirty="0"/>
+          </a:p>
+          <a:p>
+            <a:pPr indent="0" marL="0">
+              <a:buNone/>
+            </a:pPr>
+            <a:r>
+              <a:rPr lang="en-US" sz="1300" b="1" dirty="0">
+                <a:solidFill>
+                  <a:schemeClr val="tx1"/>
+                </a:solidFill>
+              </a:rPr>
               <a:t>Found something odd? </a:t>
             </a:r>
             <a:pPr indent="0" marL="0">
@@ -6484,7 +6320,7 @@
                   <a:schemeClr val="accent2"/>
                 </a:solidFill>
               </a:rPr>
-              <a:t>Then Claude runs its own checks and takes the screenshots for the owner.</a:t>
+              <a:t>Then Claude runs its own checks and takes the screenshots for the approved reviewers.</a:t>
             </a:r>
             <a:endParaRPr lang="en-US" sz="1300" dirty="0"/>
           </a:p>
@@ -6492,7 +6328,7 @@
       </p:sp>
       <p:pic>
         <p:nvPicPr>
-          <p:cNvPr id="21" name="Brick bench with the bricks hidden and the sag warning" descr="small/bb-frame.jpg">    </p:cNvPr>
+          <p:cNvPr id="21" name="Brick bench with the bricks hidden and the sag warning" descr="Claude guiding a check beside the local Brick bench site">    </p:cNvPr>
           <p:cNvPicPr>
             <a:picLocks noChangeAspect="1"/>
           </p:cNvPicPr>
@@ -6506,8 +6342,8 @@
         </p:blipFill>
         <p:spPr>
           <a:xfrm>
-            <a:off x="5760720" y="1097280"/>
-            <a:ext cx="2926080" cy="1672046"/>
+            <a:off x="5577840" y="1097280"/>
+            <a:ext cx="3291840" cy="1958645"/>
           </a:xfrm>
           <a:prstGeom prst="rect">
             <a:avLst/>
@@ -6529,8 +6365,8 @@
         </p:nvSpPr>
         <p:spPr>
           <a:xfrm>
-            <a:off x="5760720" y="2880360"/>
-            <a:ext cx="2926080" cy="457200"/>
+            <a:off x="5577840" y="3147365"/>
+            <a:ext cx="3291840" cy="457200"/>
           </a:xfrm>
           <a:prstGeom prst="rect">
             <a:avLst/>
@@ -6551,7 +6387,7 @@
                   <a:schemeClr val="accent2"/>
                 </a:solidFill>
               </a:rPr>
-              <a:t>Real example: the Brick bench with Bricks in 3D hidden, and its sag warning</a:t>
+              <a:t>Real example: Claude walks you through each check and waits for your answer</a:t>
             </a:r>
             <a:endParaRPr lang="en-US" sz="1100" dirty="0"/>
           </a:p>
@@ -6737,7 +6573,7 @@
                   <a:schemeClr val="tx1"/>
                 </a:solidFill>
               </a:rPr>
-              <a:t>It holds the change, a description of it, and evidence of the proposed new version: screenshots and notes. The owner reviews it, and only once they approve does it reach the real site.</a:t>
+              <a:t>It holds the change, a description of it, and evidence of the proposed new version: screenshots and notes. The approved reviewers check it, and only once they approve does it reach the real site.</a:t>
             </a:r>
             <a:endParaRPr lang="en-US" sz="1300" dirty="0"/>
           </a:p>
@@ -6893,284 +6729,6 @@
             <a:fld id="{F7021451-1387-4CA6-816F-3879F97B5CBC}" type="slidenum">
               <a:rPr b="0" lang="en-US"/>
               <a:t>19</a:t>
-            </a:fld>
-            <a:endParaRPr lang="en-US"/>
-          </a:p>
-        </p:txBody>
-      </p:sp>
-    </p:spTree>
-  </p:cSld>
-  <p:clrMapOvr>
-    <a:masterClrMapping/>
-  </p:clrMapOvr>
-</p:sld>
-</file>
-
-<file path=ppt/slides/slide2.xml><?xml version="1.0" encoding="utf-8"?>
-<p:sld xmlns:a="http://schemas.openxmlformats.org/drawingml/2006/main" xmlns:r="http://schemas.openxmlformats.org/officeDocument/2006/relationships" xmlns:p="http://schemas.openxmlformats.org/presentationml/2006/main">
-  <p:cSld name="Slide 2">
-    <p:spTree>
-      <p:nvGrpSpPr>
-        <p:cNvPr id="1" name=""/>
-        <p:cNvGrpSpPr/>
-        <p:nvPr/>
-      </p:nvGrpSpPr>
-      <p:grpSpPr>
-        <a:xfrm>
-          <a:off x="0" y="0"/>
-          <a:ext cx="0" cy="0"/>
-          <a:chOff x="0" y="0"/>
-          <a:chExt cx="0" cy="0"/>
-        </a:xfrm>
-      </p:grpSpPr>
-      <p:sp>
-        <p:nvSpPr>
-          <p:cNvPr id="2" name="Text 2"/>
-          <p:cNvSpPr/>
-          <p:nvPr>
-            <p:ph idx="103" type="title" hasCustomPrompt="1"/>
-          </p:nvPr>
-        </p:nvSpPr>
-        <p:spPr>
-          <a:xfrm>
-            <a:off x="457200" y="502920"/>
-            <a:ext cx="8229600" cy="457200"/>
-          </a:xfrm>
-          <a:prstGeom prst="rect">
-            <a:avLst/>
-          </a:prstGeom>
-          <a:noFill/>
-          <a:ln/>
-        </p:spPr>
-        <p:txBody>
-          <a:bodyPr wrap="square" lIns="0" tIns="0" rIns="0" bIns="0" rtlCol="0" anchor="ctr"/>
-          <a:lstStyle/>
-          <a:p>
-            <a:pPr algn="l" indent="0" marL="0">
-              <a:buNone/>
-            </a:pPr>
-            <a:r>
-              <a:rPr lang="en-US" sz="2000" b="1" spc="200" kern="0" dirty="0">
-                <a:solidFill>
-                  <a:schemeClr val="tx1"/>
-                </a:solidFill>
-              </a:rPr>
-              <a:t>LEGO FOR ADULTS, SIZED BY ANYONE</a:t>
-            </a:r>
-            <a:endParaRPr lang="en-US" sz="2000" dirty="0"/>
-          </a:p>
-        </p:txBody>
-      </p:sp>
-      <p:sp>
-        <p:nvSpPr>
-          <p:cNvPr id="3" name="Text 1"/>
-          <p:cNvSpPr txBox="1"/>
-          <p:nvPr/>
-        </p:nvSpPr>
-        <p:spPr>
-          <a:xfrm>
-            <a:off x="457200" y="960120"/>
-            <a:ext cx="8229600" cy="548640"/>
-          </a:xfrm>
-          <a:prstGeom prst="rect">
-            <a:avLst/>
-          </a:prstGeom>
-          <a:noFill/>
-          <a:ln/>
-        </p:spPr>
-        <p:txBody>
-          <a:bodyPr wrap="square" lIns="0" tIns="0" rIns="0" bIns="0" rtlCol="0" anchor="t"/>
-          <a:lstStyle/>
-          <a:p>
-            <a:pPr indent="0" marL="0">
-              <a:buNone/>
-            </a:pPr>
-            <a:r>
-              <a:rPr lang="en-US" sz="1500" dirty="0">
-                <a:solidFill>
-                  <a:schemeClr val="accent2"/>
-                </a:solidFill>
-              </a:rPr>
-              <a:t>Standard parts you can buy anywhere, snapped together into furniture people size themselves. Each piece is a page on the site, picked from the top menu: a configurator.</a:t>
-            </a:r>
-            <a:endParaRPr lang="en-US" sz="1500" dirty="0"/>
-          </a:p>
-        </p:txBody>
-      </p:sp>
-      <p:pic>
-        <p:nvPicPr>
-          <p:cNvPr id="4" name="Rod shelf page" descr="small/shelf.jpg">    </p:cNvPr>
-          <p:cNvPicPr>
-            <a:picLocks noChangeAspect="1"/>
-          </p:cNvPicPr>
-          <p:nvPr/>
-        </p:nvPicPr>
-        <p:blipFill>
-          <a:blip r:embed="rId1"/>
-          <a:stretch>
-            <a:fillRect/>
-          </a:stretch>
-        </p:blipFill>
-        <p:spPr>
-          <a:xfrm>
-            <a:off x="457200" y="1645920"/>
-            <a:ext cx="3977640" cy="2270871"/>
-          </a:xfrm>
-          <a:prstGeom prst="rect">
-            <a:avLst/>
-          </a:prstGeom>
-          <a:effectLst>
-            <a:outerShdw sx="100000" sy="100000" kx="0" ky="0" algn="bl" rotWithShape="0" blurRad="76200" dist="25400" dir="5400000">
-              <a:srgbClr val="000000">
-                <a:alpha val="18000"/>
-              </a:srgbClr>
-            </a:outerShdw>
-          </a:effectLst>
-        </p:spPr>
-      </p:pic>
-      <p:pic>
-        <p:nvPicPr>
-          <p:cNvPr id="5" name="Profile desk page" descr="small/desk.jpg">    </p:cNvPr>
-          <p:cNvPicPr>
-            <a:picLocks noChangeAspect="1"/>
-          </p:cNvPicPr>
-          <p:nvPr/>
-        </p:nvPicPr>
-        <p:blipFill>
-          <a:blip r:embed="rId2"/>
-          <a:stretch>
-            <a:fillRect/>
-          </a:stretch>
-        </p:blipFill>
-        <p:spPr>
-          <a:xfrm>
-            <a:off x="4709160" y="1645920"/>
-            <a:ext cx="3977640" cy="2270871"/>
-          </a:xfrm>
-          <a:prstGeom prst="rect">
-            <a:avLst/>
-          </a:prstGeom>
-          <a:effectLst>
-            <a:outerShdw sx="100000" sy="100000" kx="0" ky="0" algn="bl" rotWithShape="0" blurRad="76200" dist="25400" dir="5400000">
-              <a:srgbClr val="000000">
-                <a:alpha val="18000"/>
-              </a:srgbClr>
-            </a:outerShdw>
-          </a:effectLst>
-        </p:spPr>
-      </p:pic>
-      <p:sp>
-        <p:nvSpPr>
-          <p:cNvPr id="6" name="Text 2"/>
-          <p:cNvSpPr txBox="1"/>
-          <p:nvPr/>
-        </p:nvSpPr>
-        <p:spPr>
-          <a:xfrm>
-            <a:off x="457200" y="4114800"/>
-            <a:ext cx="3977640" cy="365760"/>
-          </a:xfrm>
-          <a:prstGeom prst="rect">
-            <a:avLst/>
-          </a:prstGeom>
-          <a:noFill/>
-          <a:ln/>
-        </p:spPr>
-        <p:txBody>
-          <a:bodyPr wrap="square" lIns="0" tIns="0" rIns="0" bIns="0" rtlCol="0" anchor="t"/>
-          <a:lstStyle/>
-          <a:p>
-            <a:pPr algn="ctr" indent="0" marL="0">
-              <a:buNone/>
-            </a:pPr>
-            <a:r>
-              <a:rPr lang="en-US" sz="1200" dirty="0">
-                <a:solidFill>
-                  <a:schemeClr val="accent2"/>
-                </a:solidFill>
-              </a:rPr>
-              <a:t>Rod shelf: chrome rods, cross clamps, acrylic or wood sheets</a:t>
-            </a:r>
-            <a:endParaRPr lang="en-US" sz="1200" dirty="0"/>
-          </a:p>
-        </p:txBody>
-      </p:sp>
-      <p:sp>
-        <p:nvSpPr>
-          <p:cNvPr id="7" name="Text 3"/>
-          <p:cNvSpPr txBox="1"/>
-          <p:nvPr/>
-        </p:nvSpPr>
-        <p:spPr>
-          <a:xfrm>
-            <a:off x="4709160" y="4114800"/>
-            <a:ext cx="3977640" cy="365760"/>
-          </a:xfrm>
-          <a:prstGeom prst="rect">
-            <a:avLst/>
-          </a:prstGeom>
-          <a:noFill/>
-          <a:ln/>
-        </p:spPr>
-        <p:txBody>
-          <a:bodyPr wrap="square" lIns="0" tIns="0" rIns="0" bIns="0" rtlCol="0" anchor="t"/>
-          <a:lstStyle/>
-          <a:p>
-            <a:pPr algn="ctr" indent="0" marL="0">
-              <a:buNone/>
-            </a:pPr>
-            <a:r>
-              <a:rPr lang="en-US" sz="1200" dirty="0">
-                <a:solidFill>
-                  <a:schemeClr val="accent2"/>
-                </a:solidFill>
-              </a:rPr>
-              <a:t>Profile desk: T-slot aluminium, brackets, plywood top</a:t>
-            </a:r>
-            <a:endParaRPr lang="en-US" sz="1200" dirty="0"/>
-          </a:p>
-        </p:txBody>
-      </p:sp>
-      <p:sp>
-        <p:nvSpPr>
-          <p:cNvPr id="25" name="Slide Number Placeholder 0"/>
-          <p:cNvSpPr>
-            <a:spLocks noGrp="1"/>
-          </p:cNvSpPr>
-          <p:nvPr>
-            <p:ph type="sldNum" sz="quarter" idx="4294967295"/>
-          </p:nvPr>
-        </p:nvSpPr>
-        <p:spPr>
-          <a:xfrm>
-            <a:off x="8503920" y="4754880"/>
-            <a:ext cx="365760" cy="274320"/>
-          </a:xfrm>
-          <a:prstGeom prst="rect">
-            <a:avLst/>
-          </a:prstGeom>
-          <a:extLst>
-            <a:ext uri="{C572A759-6A51-4108-AA02-DFA0A04FC94B}">
-              <ma14:wrappingTextBoxFlag xmlns:ma14="http://schemas.microsoft.com/office/mac/drawingml/2011/main" val="0"/>
-            </a:ext>
-          </a:extLst>
-        </p:spPr>
-        <p:txBody>
-          <a:bodyPr/>
-          <a:lstStyle>
-            <a:lvl1pPr>
-              <a:defRPr sz="1000">
-                <a:solidFill>
-                  <a:schemeClr val="accent3"/>
-                </a:solidFill>
-              </a:defRPr>
-            </a:lvl1pPr>
-          </a:lstStyle>
-          <a:p>
-            <a:pPr algn="l"/>
-            <a:fld id="{F7021451-1387-4CA6-816F-3879F97B5CBC}" type="slidenum">
-              <a:rPr b="0" lang="en-US"/>
-              <a:t>2</a:t>
             </a:fld>
             <a:endParaRPr lang="en-US"/>
           </a:p>
@@ -7338,7 +6896,7 @@
                   <a:schemeClr val="tx1"/>
                 </a:solidFill>
               </a:rPr>
-              <a:t>Owner reviews</a:t>
+              <a:t>Approved reviewers review</a:t>
             </a:r>
             <a:endParaRPr lang="en-US" sz="1400" dirty="0"/>
           </a:p>
@@ -8591,7 +8149,7 @@
                   <a:schemeClr val="accent4"/>
                 </a:solidFill>
               </a:rPr>
-              <a:t>When you're happy, Claude sends your change to the owner for review.</a:t>
+              <a:t>When you're happy, Claude sends your change for review.</a:t>
             </a:r>
             <a:endParaRPr lang="en-US" sz="1400" dirty="0"/>
           </a:p>
@@ -8736,464 +8294,6 @@
             <a:fld id="{F7021451-1387-4CA6-816F-3879F97B5CBC}" type="slidenum">
               <a:rPr b="0" lang="en-US"/>
               <a:t>3</a:t>
-            </a:fld>
-            <a:endParaRPr lang="en-US"/>
-          </a:p>
-        </p:txBody>
-      </p:sp>
-    </p:spTree>
-  </p:cSld>
-  <p:clrMapOvr>
-    <a:masterClrMapping/>
-  </p:clrMapOvr>
-</p:sld>
-</file>
-
-<file path=ppt/slides/slide4.xml><?xml version="1.0" encoding="utf-8"?>
-<p:sld xmlns:a="http://schemas.openxmlformats.org/drawingml/2006/main" xmlns:r="http://schemas.openxmlformats.org/officeDocument/2006/relationships" xmlns:p="http://schemas.openxmlformats.org/presentationml/2006/main">
-  <p:cSld name="Slide 4">
-    <p:spTree>
-      <p:nvGrpSpPr>
-        <p:cNvPr id="1" name=""/>
-        <p:cNvGrpSpPr/>
-        <p:nvPr/>
-      </p:nvGrpSpPr>
-      <p:grpSpPr>
-        <a:xfrm>
-          <a:off x="0" y="0"/>
-          <a:ext cx="0" cy="0"/>
-          <a:chOff x="0" y="0"/>
-          <a:chExt cx="0" cy="0"/>
-        </a:xfrm>
-      </p:grpSpPr>
-      <p:sp>
-        <p:nvSpPr>
-          <p:cNvPr id="2" name="Text 2"/>
-          <p:cNvSpPr/>
-          <p:nvPr>
-            <p:ph idx="103" type="title" hasCustomPrompt="1"/>
-          </p:nvPr>
-        </p:nvSpPr>
-        <p:spPr>
-          <a:xfrm>
-            <a:off x="457200" y="502920"/>
-            <a:ext cx="8229600" cy="457200"/>
-          </a:xfrm>
-          <a:prstGeom prst="rect">
-            <a:avLst/>
-          </a:prstGeom>
-          <a:noFill/>
-          <a:ln/>
-        </p:spPr>
-        <p:txBody>
-          <a:bodyPr wrap="square" lIns="0" tIns="0" rIns="0" bIns="0" rtlCol="0" anchor="ctr"/>
-          <a:lstStyle/>
-          <a:p>
-            <a:pPr algn="l" indent="0" marL="0">
-              <a:buNone/>
-            </a:pPr>
-            <a:r>
-              <a:rPr lang="en-US" sz="2000" b="1" spc="200" kern="0" dirty="0">
-                <a:solidFill>
-                  <a:schemeClr val="tx1"/>
-                </a:solidFill>
-              </a:rPr>
-              <a:t>YOU DESIGN, CLAUDE BUILDS</a:t>
-            </a:r>
-            <a:endParaRPr lang="en-US" sz="2000" dirty="0"/>
-          </a:p>
-        </p:txBody>
-      </p:sp>
-      <p:sp>
-        <p:nvSpPr>
-          <p:cNvPr id="3" name="Shape 1"/>
-          <p:cNvSpPr/>
-          <p:nvPr/>
-        </p:nvSpPr>
-        <p:spPr>
-          <a:xfrm>
-            <a:off x="457200" y="1097280"/>
-            <a:ext cx="3931920" cy="3200400"/>
-          </a:xfrm>
-          <a:prstGeom prst="roundRect">
-            <a:avLst>
-              <a:gd name="adj" fmla="val 1143"/>
-            </a:avLst>
-          </a:prstGeom>
-          <a:solidFill>
-            <a:schemeClr val="bg2"/>
-          </a:solidFill>
-          <a:ln w="9525">
-            <a:solidFill>
-              <a:schemeClr val="accent4"/>
-            </a:solidFill>
-            <a:prstDash val="solid"/>
-          </a:ln>
-        </p:spPr>
-      </p:sp>
-      <p:sp>
-        <p:nvSpPr>
-          <p:cNvPr id="4" name="Shape 2"/>
-          <p:cNvSpPr/>
-          <p:nvPr/>
-        </p:nvSpPr>
-        <p:spPr>
-          <a:xfrm>
-            <a:off x="4754880" y="1097280"/>
-            <a:ext cx="3931920" cy="3200400"/>
-          </a:xfrm>
-          <a:prstGeom prst="roundRect">
-            <a:avLst>
-              <a:gd name="adj" fmla="val 1143"/>
-            </a:avLst>
-          </a:prstGeom>
-          <a:solidFill>
-            <a:schemeClr val="tx2"/>
-          </a:solidFill>
-          <a:ln w="9525">
-            <a:solidFill>
-              <a:schemeClr val="tx2"/>
-            </a:solidFill>
-            <a:prstDash val="solid"/>
-          </a:ln>
-        </p:spPr>
-      </p:sp>
-      <p:sp>
-        <p:nvSpPr>
-          <p:cNvPr id="5" name="Text 3"/>
-          <p:cNvSpPr txBox="1"/>
-          <p:nvPr/>
-        </p:nvSpPr>
-        <p:spPr>
-          <a:xfrm>
-            <a:off x="731520" y="1280160"/>
-            <a:ext cx="3474720" cy="365760"/>
-          </a:xfrm>
-          <a:prstGeom prst="rect">
-            <a:avLst/>
-          </a:prstGeom>
-          <a:noFill/>
-          <a:ln/>
-        </p:spPr>
-        <p:txBody>
-          <a:bodyPr wrap="square" lIns="0" tIns="0" rIns="0" bIns="0" rtlCol="0" anchor="t"/>
-          <a:lstStyle/>
-          <a:p>
-            <a:pPr indent="0" marL="0">
-              <a:buNone/>
-            </a:pPr>
-            <a:r>
-              <a:rPr lang="en-US" sz="1800" b="1" dirty="0">
-                <a:solidFill>
-                  <a:schemeClr val="tx1"/>
-                </a:solidFill>
-              </a:rPr>
-              <a:t>You, the designer</a:t>
-            </a:r>
-            <a:endParaRPr lang="en-US" sz="1800" dirty="0"/>
-          </a:p>
-        </p:txBody>
-      </p:sp>
-      <p:sp>
-        <p:nvSpPr>
-          <p:cNvPr id="6" name="Text 4"/>
-          <p:cNvSpPr txBox="1"/>
-          <p:nvPr/>
-        </p:nvSpPr>
-        <p:spPr>
-          <a:xfrm>
-            <a:off x="731520" y="1783080"/>
-            <a:ext cx="3474720" cy="2377440"/>
-          </a:xfrm>
-          <a:prstGeom prst="rect">
-            <a:avLst/>
-          </a:prstGeom>
-          <a:noFill/>
-          <a:ln/>
-        </p:spPr>
-        <p:txBody>
-          <a:bodyPr wrap="square" lIns="0" tIns="0" rIns="0" bIns="0" rtlCol="0" anchor="t"/>
-          <a:lstStyle/>
-          <a:p>
-            <a:pPr marL="342900" indent="-342900">
-              <a:spcAft>
-                <a:spcPts val="800"/>
-              </a:spcAft>
-              <a:buSzPct val="100000"/>
-              <a:buChar char="•"/>
-            </a:pPr>
-            <a:r>
-              <a:rPr lang="en-US" sz="1400" dirty="0">
-                <a:solidFill>
-                  <a:schemeClr val="tx1"/>
-                </a:solidFill>
-              </a:rPr>
-              <a:t>What the piece is and how it looks</a:t>
-            </a:r>
-            <a:endParaRPr lang="en-US" sz="1400" dirty="0"/>
-          </a:p>
-          <a:p>
-            <a:pPr marL="342900" indent="-342900">
-              <a:spcAft>
-                <a:spcPts val="800"/>
-              </a:spcAft>
-              <a:buSzPct val="100000"/>
-              <a:buChar char="•"/>
-            </a:pPr>
-            <a:r>
-              <a:rPr lang="en-US" sz="1400" dirty="0">
-                <a:solidFill>
-                  <a:schemeClr val="tx1"/>
-                </a:solidFill>
-              </a:rPr>
-              <a:t>Which real parts to buy, and their sizes</a:t>
-            </a:r>
-            <a:endParaRPr lang="en-US" sz="1400" dirty="0"/>
-          </a:p>
-          <a:p>
-            <a:pPr marL="342900" indent="-342900">
-              <a:spcAft>
-                <a:spcPts val="800"/>
-              </a:spcAft>
-              <a:buSzPct val="100000"/>
-              <a:buChar char="•"/>
-            </a:pPr>
-            <a:r>
-              <a:rPr lang="en-US" sz="1400" dirty="0">
-                <a:solidFill>
-                  <a:schemeClr val="tx1"/>
-                </a:solidFill>
-              </a:rPr>
-              <a:t>How it goes together, step by step</a:t>
-            </a:r>
-            <a:endParaRPr lang="en-US" sz="1400" dirty="0"/>
-          </a:p>
-          <a:p>
-            <a:pPr marL="342900" indent="-342900">
-              <a:spcAft>
-                <a:spcPts val="800"/>
-              </a:spcAft>
-              <a:buSzPct val="100000"/>
-              <a:buChar char="•"/>
-            </a:pPr>
-            <a:r>
-              <a:rPr lang="en-US" sz="1400" dirty="0">
-                <a:solidFill>
-                  <a:schemeClr val="tx1"/>
-                </a:solidFill>
-              </a:rPr>
-              <a:t>What people can change, and the limits</a:t>
-            </a:r>
-            <a:endParaRPr lang="en-US" sz="1400" dirty="0"/>
-          </a:p>
-          <a:p>
-            <a:pPr marL="342900" indent="-342900">
-              <a:spcAft>
-                <a:spcPts val="800"/>
-              </a:spcAft>
-              <a:buSzPct val="100000"/>
-              <a:buChar char="•"/>
-            </a:pPr>
-            <a:r>
-              <a:rPr lang="en-US" sz="1400" dirty="0">
-                <a:solidFill>
-                  <a:schemeClr val="tx1"/>
-                </a:solidFill>
-              </a:rPr>
-              <a:t>Saying "yes, that looks right" or "move this"</a:t>
-            </a:r>
-            <a:endParaRPr lang="en-US" sz="1400" dirty="0"/>
-          </a:p>
-        </p:txBody>
-      </p:sp>
-      <p:sp>
-        <p:nvSpPr>
-          <p:cNvPr id="7" name="Text 5"/>
-          <p:cNvSpPr txBox="1"/>
-          <p:nvPr/>
-        </p:nvSpPr>
-        <p:spPr>
-          <a:xfrm>
-            <a:off x="5029200" y="1280160"/>
-            <a:ext cx="3474720" cy="365760"/>
-          </a:xfrm>
-          <a:prstGeom prst="rect">
-            <a:avLst/>
-          </a:prstGeom>
-          <a:noFill/>
-          <a:ln/>
-        </p:spPr>
-        <p:txBody>
-          <a:bodyPr wrap="square" lIns="0" tIns="0" rIns="0" bIns="0" rtlCol="0" anchor="t"/>
-          <a:lstStyle/>
-          <a:p>
-            <a:pPr indent="0" marL="0">
-              <a:buNone/>
-            </a:pPr>
-            <a:r>
-              <a:rPr lang="en-US" sz="1800" b="1" dirty="0">
-                <a:solidFill>
-                  <a:schemeClr val="bg1"/>
-                </a:solidFill>
-              </a:rPr>
-              <a:t>Claude, in the desktop app</a:t>
-            </a:r>
-            <a:endParaRPr lang="en-US" sz="1800" dirty="0"/>
-          </a:p>
-        </p:txBody>
-      </p:sp>
-      <p:sp>
-        <p:nvSpPr>
-          <p:cNvPr id="8" name="Text 6"/>
-          <p:cNvSpPr txBox="1"/>
-          <p:nvPr/>
-        </p:nvSpPr>
-        <p:spPr>
-          <a:xfrm>
-            <a:off x="5029200" y="1783080"/>
-            <a:ext cx="3474720" cy="2377440"/>
-          </a:xfrm>
-          <a:prstGeom prst="rect">
-            <a:avLst/>
-          </a:prstGeom>
-          <a:noFill/>
-          <a:ln/>
-        </p:spPr>
-        <p:txBody>
-          <a:bodyPr wrap="square" lIns="0" tIns="0" rIns="0" bIns="0" rtlCol="0" anchor="t"/>
-          <a:lstStyle/>
-          <a:p>
-            <a:pPr marL="342900" indent="-342900">
-              <a:spcAft>
-                <a:spcPts val="800"/>
-              </a:spcAft>
-              <a:buSzPct val="100000"/>
-              <a:buChar char="•"/>
-            </a:pPr>
-            <a:r>
-              <a:rPr lang="en-US" sz="1400" dirty="0">
-                <a:solidFill>
-                  <a:schemeClr val="bg1"/>
-                </a:solidFill>
-              </a:rPr>
-              <a:t>Runs the private copy of the site for you</a:t>
-            </a:r>
-            <a:endParaRPr lang="en-US" sz="1400" dirty="0"/>
-          </a:p>
-          <a:p>
-            <a:pPr marL="342900" indent="-342900">
-              <a:spcAft>
-                <a:spcPts val="800"/>
-              </a:spcAft>
-              <a:buSzPct val="100000"/>
-              <a:buChar char="•"/>
-            </a:pPr>
-            <a:r>
-              <a:rPr lang="en-US" sz="1400" dirty="0">
-                <a:solidFill>
-                  <a:schemeClr val="bg1"/>
-                </a:solidFill>
-              </a:rPr>
-              <a:t>Writes the code and the tests</a:t>
-            </a:r>
-            <a:endParaRPr lang="en-US" sz="1400" dirty="0"/>
-          </a:p>
-          <a:p>
-            <a:pPr marL="342900" indent="-342900">
-              <a:spcAft>
-                <a:spcPts val="800"/>
-              </a:spcAft>
-              <a:buSzPct val="100000"/>
-              <a:buChar char="•"/>
-            </a:pPr>
-            <a:r>
-              <a:rPr lang="en-US" sz="1400" dirty="0">
-                <a:solidFill>
-                  <a:schemeClr val="bg1"/>
-                </a:solidFill>
-              </a:rPr>
-              <a:t>Shows you what changed after every round</a:t>
-            </a:r>
-            <a:endParaRPr lang="en-US" sz="1400" dirty="0"/>
-          </a:p>
-          <a:p>
-            <a:pPr marL="342900" indent="-342900">
-              <a:spcAft>
-                <a:spcPts val="800"/>
-              </a:spcAft>
-              <a:buSzPct val="100000"/>
-              <a:buChar char="•"/>
-            </a:pPr>
-            <a:r>
-              <a:rPr lang="en-US" sz="1400" dirty="0">
-                <a:solidFill>
-                  <a:schemeClr val="bg1"/>
-                </a:solidFill>
-              </a:rPr>
-              <a:t>Saves versions as it goes</a:t>
-            </a:r>
-            <a:endParaRPr lang="en-US" sz="1400" dirty="0"/>
-          </a:p>
-          <a:p>
-            <a:pPr marL="342900" indent="-342900">
-              <a:spcAft>
-                <a:spcPts val="800"/>
-              </a:spcAft>
-              <a:buSzPct val="100000"/>
-              <a:buChar char="•"/>
-            </a:pPr>
-            <a:r>
-              <a:rPr lang="en-US" sz="1400" dirty="0">
-                <a:solidFill>
-                  <a:schemeClr val="bg1"/>
-                </a:solidFill>
-              </a:rPr>
-              <a:t>Sends your change for review</a:t>
-            </a:r>
-            <a:endParaRPr lang="en-US" sz="1400" dirty="0"/>
-          </a:p>
-        </p:txBody>
-      </p:sp>
-      <p:sp>
-        <p:nvSpPr>
-          <p:cNvPr id="25" name="Slide Number Placeholder 0"/>
-          <p:cNvSpPr>
-            <a:spLocks noGrp="1"/>
-          </p:cNvSpPr>
-          <p:nvPr>
-            <p:ph type="sldNum" sz="quarter" idx="4294967295"/>
-          </p:nvPr>
-        </p:nvSpPr>
-        <p:spPr>
-          <a:xfrm>
-            <a:off x="8503920" y="4754880"/>
-            <a:ext cx="365760" cy="274320"/>
-          </a:xfrm>
-          <a:prstGeom prst="rect">
-            <a:avLst/>
-          </a:prstGeom>
-          <a:extLst>
-            <a:ext uri="{C572A759-6A51-4108-AA02-DFA0A04FC94B}">
-              <ma14:wrappingTextBoxFlag xmlns:ma14="http://schemas.microsoft.com/office/mac/drawingml/2011/main" val="0"/>
-            </a:ext>
-          </a:extLst>
-        </p:spPr>
-        <p:txBody>
-          <a:bodyPr/>
-          <a:lstStyle>
-            <a:lvl1pPr>
-              <a:defRPr sz="1000">
-                <a:solidFill>
-                  <a:schemeClr val="accent3"/>
-                </a:solidFill>
-              </a:defRPr>
-            </a:lvl1pPr>
-          </a:lstStyle>
-          <a:p>
-            <a:pPr algn="l"/>
-            <a:fld id="{F7021451-1387-4CA6-816F-3879F97B5CBC}" type="slidenum">
-              <a:rPr b="0" lang="en-US"/>
-              <a:t>4</a:t>
             </a:fld>
             <a:endParaRPr lang="en-US"/>
           </a:p>
@@ -9733,8 +8833,8 @@
         </p:blipFill>
         <p:spPr>
           <a:xfrm>
-            <a:off x="457200" y="1051560"/>
-            <a:ext cx="5852160" cy="3323191"/>
+            <a:off x="457200" y="1216222"/>
+            <a:ext cx="5852160" cy="2993866"/>
           </a:xfrm>
           <a:prstGeom prst="rect">
             <a:avLst/>
@@ -10017,8 +9117,8 @@
         </p:blipFill>
         <p:spPr>
           <a:xfrm>
-            <a:off x="457200" y="1051560"/>
-            <a:ext cx="5852160" cy="3323191"/>
+            <a:off x="457200" y="1216222"/>
+            <a:ext cx="5852160" cy="2993866"/>
           </a:xfrm>
           <a:prstGeom prst="rect">
             <a:avLst/>
@@ -10128,7 +9228,7 @@
                   <a:schemeClr val="accent2"/>
                 </a:solidFill>
               </a:rPr>
-              <a:t>In the left sidebar, click Code. This is the part of the app that works on projects, not just chats.</a:t>
+              <a:t>At the top of the sidebar, click the Code button (the &lt;/&gt; icon). This is the part of the app that works on projects, not just chats.</a:t>
             </a:r>
             <a:endParaRPr lang="en-US" sz="1400" dirty="0"/>
           </a:p>

</xml_diff>

<commit_message>
Tighten the contributor guide deck: merge steps 3 and 4, link URLs, add real PR link
Merge the paste and Claude takes over steps into one slide, narrow the
before-sending checklist and enlarge its screenshot, remove the Claude
instruction box on the last step, link it to a real pull request, and make the
URLs on the deck clickable.

Co-Authored-By: Claude Sonnet 5.5 <noreply@anthropic.com>
</commit_message>
<xml_diff>
--- a/docs/contributing-guide.pptx
+++ b/docs/contributing-guide.pptx
@@ -13,7 +13,6 @@
     <p:sldId id="263" r:id="rId9"/>
     <p:sldId id="264" r:id="rId10"/>
     <p:sldId id="265" r:id="rId11"/>
-    <p:sldId id="266" r:id="rId12"/>
     <p:sldId id="267" r:id="rId13"/>
     <p:sldId id="270" r:id="rId16"/>
     <p:sldId id="272" r:id="rId18"/>
@@ -653,7 +652,7 @@
           <a:p>
             <a:r>
               <a:rPr lang="en-US" dirty="0"/>
-              <a:t>Illustration. "Clone" means download the project. Claude needs Git for it; if it is missing, Claude gives you the one link to install it. The project carries Claude's instructions, so as soon as it is downloaded Claude knows how to guide you.</a:t>
+              <a:t>Simulated conversation; exact wording will vary. Next time, skip this step: click Choose…, pick the open-source-modular-furniture folder in Documents and say "let's work on this". Illustration. "Clone" means download the project. Claude needs Git for it; if it is missing, Claude gives you the one link to install it. The project carries Claude's instructions, so as soon as it is downloaded Claude knows how to guide you.</a:t>
             </a:r>
             <a:endParaRPr lang="en-US" dirty="0"/>
           </a:p>
@@ -677,94 +676,6 @@
             <a:fld id="{F7021451-1387-4CA6-816F-3879F97B5CBC}" type="slidenum">
               <a:rPr lang="en-US"/>
               <a:t>10</a:t>
-            </a:fld>
-            <a:endParaRPr lang="en-US"/>
-          </a:p>
-        </p:txBody>
-      </p:sp>
-    </p:spTree>
-    <p:extLst>
-      <p:ext uri="{BB962C8B-B14F-4D97-AF65-F5344CB8AC3E}">
-        <p14:creationId xmlns:p14="http://schemas.microsoft.com/office/powerpoint/2010/main" val="1024086991"/>
-      </p:ext>
-    </p:extLst>
-  </p:cSld>
-  <p:clrMapOvr>
-    <a:masterClrMapping/>
-  </p:clrMapOvr>
-</p:notes>
-</file>
-
-<file path=ppt/notesSlides/notesSlide11.xml><?xml version="1.0" encoding="utf-8"?>
-<p:notes xmlns:a="http://schemas.openxmlformats.org/drawingml/2006/main" xmlns:r="http://schemas.openxmlformats.org/officeDocument/2006/relationships" xmlns:p="http://schemas.openxmlformats.org/presentationml/2006/main">
-  <p:cSld>
-    <p:spTree>
-      <p:nvGrpSpPr>
-        <p:cNvPr id="1" name=""/>
-        <p:cNvGrpSpPr/>
-        <p:nvPr/>
-      </p:nvGrpSpPr>
-      <p:grpSpPr>
-        <a:xfrm>
-          <a:off x="0" y="0"/>
-          <a:ext cx="0" cy="0"/>
-          <a:chOff x="0" y="0"/>
-          <a:chExt cx="0" cy="0"/>
-        </a:xfrm>
-      </p:grpSpPr>
-      <p:sp>
-        <p:nvSpPr>
-          <p:cNvPr id="2" name="Slide Image Placeholder 1"/>
-          <p:cNvSpPr>
-            <a:spLocks noGrp="1" noRot="1" noChangeAspect="1"/>
-          </p:cNvSpPr>
-          <p:nvPr>
-            <p:ph type="sldImg"/>
-          </p:nvPr>
-        </p:nvSpPr>
-        <p:spPr/>
-      </p:sp>
-      <p:sp>
-        <p:nvSpPr>
-          <p:cNvPr id="3" name="Notes Placeholder 2"/>
-          <p:cNvSpPr>
-            <a:spLocks noGrp="1"/>
-          </p:cNvSpPr>
-          <p:nvPr>
-            <p:ph type="body" idx="1"/>
-          </p:nvPr>
-        </p:nvSpPr>
-        <p:spPr/>
-        <p:txBody>
-          <a:bodyPr/>
-          <a:lstStyle/>
-          <a:p>
-            <a:r>
-              <a:rPr lang="en-US" dirty="0"/>
-              <a:t>Simulated conversation; exact wording will vary. Next time, skip step 3: click Choose…, pick the open-source-modular-furniture folder in Documents and say "let's work on this".</a:t>
-            </a:r>
-            <a:endParaRPr lang="en-US" dirty="0"/>
-          </a:p>
-        </p:txBody>
-      </p:sp>
-      <p:sp>
-        <p:nvSpPr>
-          <p:cNvPr id="4" name="Slide Number Placeholder 3"/>
-          <p:cNvSpPr>
-            <a:spLocks noGrp="1"/>
-          </p:cNvSpPr>
-          <p:nvPr>
-            <p:ph type="sldNum" sz="quarter" idx="10"/>
-          </p:nvPr>
-        </p:nvSpPr>
-        <p:spPr/>
-        <p:txBody>
-          <a:bodyPr/>
-          <a:lstStyle/>
-          <a:p>
-            <a:fld id="{F7021451-1387-4CA6-816F-3879F97B5CBC}" type="slidenum">
-              <a:rPr lang="en-US"/>
-              <a:t>11</a:t>
             </a:fld>
             <a:endParaRPr lang="en-US"/>
           </a:p>
@@ -2746,7 +2657,7 @@
                   <a:schemeClr val="tx1"/>
                 </a:solidFill>
               </a:rPr>
-              <a:t>STEP 3: TELL CLAUDE THE PROJECT</a:t>
+              <a:t>STEP 3: PASTE IT, CLAUDE TAKES OVER</a:t>
             </a:r>
             <a:endParaRPr lang="en-US" sz="2000" dirty="0"/>
           </a:p>
@@ -2789,7 +2700,7 @@
                 <a:ea typeface="Courier New" pitchFamily="34" charset="-122"/>
                 <a:cs typeface="Courier New" pitchFamily="34" charset="-120"/>
               </a:rPr>
-              <a:t>ILLUSTRATION</a:t>
+              <a:t>SIMULATED EXAMPLE</a:t>
             </a:r>
             <a:endParaRPr lang="en-US" sz="800" dirty="0"/>
           </a:p>
@@ -2797,7 +2708,7 @@
       </p:sp>
       <p:pic>
         <p:nvPicPr>
-          <p:cNvPr id="4" name="Step 3: tell Claude the project" descr="small/app-first.jpg">    </p:cNvPr>
+          <p:cNvPr id="4" name="Step 3: tell Claude the project" descr="Claude Code session after pasting the repository link"/>
           <p:cNvPicPr>
             <a:picLocks noChangeAspect="1"/>
           </p:cNvPicPr>
@@ -2811,14 +2722,14 @@
         </p:blipFill>
         <p:spPr>
           <a:xfrm>
-            <a:off x="457200" y="1051560"/>
-            <a:ext cx="4605311" cy="3611880"/>
+            <a:off x="457200" y="1005840"/>
+            <a:ext cx="3291840" cy="2581743"/>
           </a:xfrm>
           <a:prstGeom prst="rect">
             <a:avLst/>
           </a:prstGeom>
           <a:effectLst>
-            <a:outerShdw sx="100000" sy="100000" kx="0" ky="0" algn="bl" rotWithShape="0" blurRad="76200" dist="25400" dir="5400000">
+            <a:outerShdw blurRad="76200" dist="25400" dir="5400000" algn="bl" rotWithShape="0">
               <a:srgbClr val="000000">
                 <a:alpha val="18000"/>
               </a:srgbClr>
@@ -2826,16 +2737,47 @@
           </a:effectLst>
         </p:spPr>
       </p:pic>
-      <p:sp>
-        <p:nvSpPr>
-          <p:cNvPr id="5" name="Text 2"/>
+      <p:pic>
+        <p:nvPicPr>
+          <p:cNvPr id="5" name="Step 4: Claude takes it from there" descr="Simulated start of the work"/>
+          <p:cNvPicPr>
+            <a:picLocks noChangeAspect="1"/>
+          </p:cNvPicPr>
+          <p:nvPr/>
+        </p:nvPicPr>
+        <p:blipFill>
+          <a:blip r:embed="rId90"/>
+          <a:stretch>
+            <a:fillRect/>
+          </a:stretch>
+        </p:blipFill>
+        <p:spPr>
+          <a:xfrm>
+            <a:off x="5394960" y="1005840"/>
+            <a:ext cx="3291840" cy="2299585"/>
+          </a:xfrm>
+          <a:prstGeom prst="rect">
+            <a:avLst/>
+          </a:prstGeom>
+          <a:effectLst>
+            <a:outerShdw blurRad="76200" dist="25400" dir="5400000" algn="bl" rotWithShape="0">
+              <a:srgbClr val="000000">
+                <a:alpha val="18000"/>
+              </a:srgbClr>
+            </a:outerShdw>
+          </a:effectLst>
+        </p:spPr>
+      </p:pic>
+      <p:sp>
+        <p:nvSpPr>
+          <p:cNvPr id="6" name="Step number 3"/>
           <p:cNvSpPr txBox="1"/>
           <p:nvPr/>
         </p:nvSpPr>
         <p:spPr>
           <a:xfrm>
-            <a:off x="6583680" y="1188720"/>
-            <a:ext cx="548640" cy="548640"/>
+            <a:off x="457200" y="3679023"/>
+            <a:ext cx="320040" cy="320040"/>
           </a:xfrm>
           <a:prstGeom prst="ellipse">
             <a:avLst/>
@@ -2843,88 +2785,162 @@
           <a:solidFill>
             <a:schemeClr val="accent1"/>
           </a:solidFill>
-          <a:ln/>
-        </p:spPr>
-        <p:txBody>
-          <a:bodyPr wrap="square" lIns="0" tIns="0" rIns="0" bIns="0" rtlCol="0" anchor="ctr"/>
-          <a:lstStyle/>
-          <a:p>
-            <a:pPr algn="ctr" indent="0" marL="0">
-              <a:buNone/>
-            </a:pPr>
-            <a:r>
-              <a:rPr lang="en-US" sz="1400" b="1" dirty="0">
+        </p:spPr>
+        <p:txBody>
+          <a:bodyPr wrap="square" lIns="0" tIns="0" rIns="0" bIns="0" anchor="ctr"/>
+          <a:lstStyle/>
+          <a:p>
+            <a:pPr algn="ctr"/>
+            <a:r>
+              <a:rPr lang="en-US" sz="1200" b="1" dirty="0">
                 <a:solidFill>
                   <a:schemeClr val="bg1"/>
                 </a:solidFill>
               </a:rPr>
               <a:t>3</a:t>
             </a:r>
-            <a:endParaRPr lang="en-US" sz="1400" dirty="0"/>
-          </a:p>
-        </p:txBody>
-      </p:sp>
-      <p:sp>
-        <p:nvSpPr>
-          <p:cNvPr id="6" name="Text 3"/>
+          </a:p>
+        </p:txBody>
+      </p:sp>
+      <p:sp>
+        <p:nvSpPr>
+          <p:cNvPr id="7" name="Step number 4"/>
           <p:cNvSpPr txBox="1"/>
           <p:nvPr/>
         </p:nvSpPr>
         <p:spPr>
           <a:xfrm>
-            <a:off x="6583680" y="1920240"/>
-            <a:ext cx="2194560" cy="2651760"/>
+            <a:off x="5394960" y="3679023"/>
+            <a:ext cx="320040" cy="320040"/>
+          </a:xfrm>
+          <a:prstGeom prst="ellipse">
+            <a:avLst/>
+          </a:prstGeom>
+          <a:solidFill>
+            <a:schemeClr val="accent1"/>
+          </a:solidFill>
+        </p:spPr>
+        <p:txBody>
+          <a:bodyPr wrap="square" lIns="0" tIns="0" rIns="0" bIns="0" anchor="ctr"/>
+          <a:lstStyle/>
+          <a:p>
+            <a:pPr algn="ctr"/>
+            <a:r>
+              <a:rPr lang="en-US" sz="1200" b="1" dirty="0">
+                <a:solidFill>
+                  <a:schemeClr val="bg1"/>
+                </a:solidFill>
+              </a:rPr>
+              <a:t>4</a:t>
+            </a:r>
+          </a:p>
+        </p:txBody>
+      </p:sp>
+      <p:sp>
+        <p:nvSpPr>
+          <p:cNvPr id="30" name="Step 3 text"/>
+          <p:cNvSpPr txBox="1"/>
+          <p:nvPr/>
+        </p:nvSpPr>
+        <p:spPr>
+          <a:xfrm>
+            <a:off x="868680" y="3679023"/>
+            <a:ext cx="2880360" cy="1005840"/>
           </a:xfrm>
           <a:prstGeom prst="rect">
             <a:avLst/>
           </a:prstGeom>
           <a:noFill/>
-          <a:ln/>
-        </p:spPr>
-        <p:txBody>
-          <a:bodyPr wrap="square" lIns="0" tIns="0" rIns="0" bIns="0" rtlCol="0" anchor="t"/>
+        </p:spPr>
+        <p:txBody>
+          <a:bodyPr wrap="square" lIns="0" tIns="0" rIns="0" bIns="0" anchor="t"/>
           <a:lstStyle/>
           <a:p>
             <a:pPr indent="0" marL="0">
               <a:buNone/>
             </a:pPr>
             <a:r>
-              <a:rPr lang="en-US" sz="1700" b="1" dirty="0">
+              <a:rPr lang="en-US" sz="1300" b="1" dirty="0">
                 <a:solidFill>
                   <a:schemeClr val="tx1"/>
                 </a:solidFill>
               </a:rPr>
               <a:t>Paste this</a:t>
             </a:r>
-            <a:endParaRPr lang="en-US" sz="1400" dirty="0"/>
           </a:p>
           <a:p>
             <a:pPr indent="0" marL="0">
               <a:buNone/>
             </a:pPr>
             <a:r>
-              <a:rPr lang="en-US" sz="800" dirty="0">
+              <a:rPr lang="en-US" sz="1100" b="0" dirty="0">
+                <a:solidFill>
+                  <a:schemeClr val="accent2"/>
+                </a:solidFill>
+              </a:rPr>
+              <a:t>"I want to work on this repository </a:t>
+            </a:r>
+            <a:r>
+              <a:rPr lang="en-US" sz="1100" dirty="0">
+                <a:hlinkClick r:id="rId900"/>
+              </a:rPr>
+              <a:t>https://github.com/mfprado/open-source-modular-furniture</a:t>
+            </a:r>
+            <a:r>
+              <a:rPr lang="en-US" sz="1100" b="0" dirty="0">
+                <a:solidFill>
+                  <a:schemeClr val="accent2"/>
+                </a:solidFill>
+              </a:rPr>
+              <a:t>. Clone it and let's start working there."</a:t>
+            </a:r>
+          </a:p>
+        </p:txBody>
+      </p:sp>
+      <p:sp>
+        <p:nvSpPr>
+          <p:cNvPr id="31" name="Step 4 text"/>
+          <p:cNvSpPr txBox="1"/>
+          <p:nvPr/>
+        </p:nvSpPr>
+        <p:spPr>
+          <a:xfrm>
+            <a:off x="5806440" y="3679023"/>
+            <a:ext cx="2880360" cy="1005840"/>
+          </a:xfrm>
+          <a:prstGeom prst="rect">
+            <a:avLst/>
+          </a:prstGeom>
+          <a:noFill/>
+        </p:spPr>
+        <p:txBody>
+          <a:bodyPr wrap="square" lIns="0" tIns="0" rIns="0" bIns="0" anchor="t"/>
+          <a:lstStyle/>
+          <a:p>
+            <a:pPr indent="0" marL="0">
+              <a:buNone/>
+            </a:pPr>
+            <a:r>
+              <a:rPr lang="en-US" sz="1300" b="1" dirty="0">
                 <a:solidFill>
                   <a:schemeClr val="tx1"/>
                 </a:solidFill>
               </a:rPr>
-              <a:t> </a:t>
-            </a:r>
-            <a:endParaRPr lang="en-US" sz="1400" dirty="0"/>
+              <a:t>Claude takes it from there</a:t>
+            </a:r>
           </a:p>
           <a:p>
             <a:pPr indent="0" marL="0">
               <a:buNone/>
             </a:pPr>
             <a:r>
-              <a:rPr lang="en-US" sz="1400" dirty="0">
+              <a:rPr lang="en-US" sz="1100" b="0" dirty="0">
                 <a:solidFill>
                   <a:schemeClr val="accent2"/>
                 </a:solidFill>
               </a:rPr>
-              <a:t>"I want to work on this repository https://github.com/mfprado/open-source-modular-furniture. Clone it and let's start working there."</a:t>
-            </a:r>
-            <a:endParaRPr lang="en-US" sz="1400" dirty="0"/>
+              <a:t>The project carries step-by-step instructions for Claude, so it guides you. Click your answers: Claude asks with buttons. It starts your private copy and tells you where to open it.</a:t>
+            </a:r>
           </a:p>
         </p:txBody>
       </p:sp>
@@ -2968,322 +2984,6 @@
             <a:fld id="{F7021451-1387-4CA6-816F-3879F97B5CBC}" type="slidenum">
               <a:rPr b="0" lang="en-US"/>
               <a:t>10</a:t>
-            </a:fld>
-            <a:endParaRPr lang="en-US"/>
-          </a:p>
-        </p:txBody>
-      </p:sp>
-    </p:spTree>
-  </p:cSld>
-  <p:clrMapOvr>
-    <a:masterClrMapping/>
-  </p:clrMapOvr>
-</p:sld>
-</file>
-
-<file path=ppt/slides/slide11.xml><?xml version="1.0" encoding="utf-8"?>
-<p:sld xmlns:a="http://schemas.openxmlformats.org/drawingml/2006/main" xmlns:r="http://schemas.openxmlformats.org/officeDocument/2006/relationships" xmlns:p="http://schemas.openxmlformats.org/presentationml/2006/main">
-  <p:cSld name="Slide 11">
-    <p:spTree>
-      <p:nvGrpSpPr>
-        <p:cNvPr id="1" name=""/>
-        <p:cNvGrpSpPr/>
-        <p:nvPr/>
-      </p:nvGrpSpPr>
-      <p:grpSpPr>
-        <a:xfrm>
-          <a:off x="0" y="0"/>
-          <a:ext cx="0" cy="0"/>
-          <a:chOff x="0" y="0"/>
-          <a:chExt cx="0" cy="0"/>
-        </a:xfrm>
-      </p:grpSpPr>
-      <p:sp>
-        <p:nvSpPr>
-          <p:cNvPr id="2" name="Text 2"/>
-          <p:cNvSpPr/>
-          <p:nvPr>
-            <p:ph idx="103" type="title" hasCustomPrompt="1"/>
-          </p:nvPr>
-        </p:nvSpPr>
-        <p:spPr>
-          <a:xfrm>
-            <a:off x="457200" y="502920"/>
-            <a:ext cx="8229600" cy="457200"/>
-          </a:xfrm>
-          <a:prstGeom prst="rect">
-            <a:avLst/>
-          </a:prstGeom>
-          <a:noFill/>
-          <a:ln/>
-        </p:spPr>
-        <p:txBody>
-          <a:bodyPr wrap="square" lIns="0" tIns="0" rIns="0" bIns="0" rtlCol="0" anchor="ctr"/>
-          <a:lstStyle/>
-          <a:p>
-            <a:pPr algn="l" indent="0" marL="0">
-              <a:buNone/>
-            </a:pPr>
-            <a:r>
-              <a:rPr lang="en-US" sz="2000" b="1" spc="200" kern="0" dirty="0">
-                <a:solidFill>
-                  <a:schemeClr val="tx1"/>
-                </a:solidFill>
-              </a:rPr>
-              <a:t>STEP 4: CLAUDE TAKES IT FROM THERE</a:t>
-            </a:r>
-            <a:endParaRPr lang="en-US" sz="2000" dirty="0"/>
-          </a:p>
-        </p:txBody>
-      </p:sp>
-      <p:sp>
-        <p:nvSpPr>
-          <p:cNvPr id="3" name="SIMULATED EXAMPLE tag"/>
-          <p:cNvSpPr txBox="1"/>
-          <p:nvPr/>
-        </p:nvSpPr>
-        <p:spPr>
-          <a:xfrm>
-            <a:off x="6949440" y="73152"/>
-            <a:ext cx="1920240" cy="237744"/>
-          </a:xfrm>
-          <a:prstGeom prst="rect">
-            <a:avLst/>
-          </a:prstGeom>
-          <a:noFill/>
-          <a:ln w="9525">
-            <a:solidFill>
-              <a:srgbClr val="8A8F94"/>
-            </a:solidFill>
-          </a:ln>
-        </p:spPr>
-        <p:txBody>
-          <a:bodyPr wrap="square" lIns="0" tIns="0" rIns="0" bIns="0" rtlCol="0" anchor="ctr"/>
-          <a:lstStyle/>
-          <a:p>
-            <a:pPr algn="ctr" indent="0" marL="0">
-              <a:buNone/>
-            </a:pPr>
-            <a:r>
-              <a:rPr lang="en-US" sz="800" b="1" spc="100" kern="0" dirty="0">
-                <a:solidFill>
-                  <a:srgbClr val="E9EBED"/>
-                </a:solidFill>
-                <a:latin typeface="Courier New" pitchFamily="34" charset="0"/>
-                <a:ea typeface="Courier New" pitchFamily="34" charset="-122"/>
-                <a:cs typeface="Courier New" pitchFamily="34" charset="-120"/>
-              </a:rPr>
-              <a:t>SIMULATED EXAMPLE</a:t>
-            </a:r>
-            <a:endParaRPr lang="en-US" sz="800" dirty="0"/>
-          </a:p>
-        </p:txBody>
-      </p:sp>
-      <p:pic>
-        <p:nvPicPr>
-          <p:cNvPr id="4" name="Simulated start of the work" descr="small/app-start.jpg">    </p:cNvPr>
-          <p:cNvPicPr>
-            <a:picLocks noChangeAspect="1"/>
-          </p:cNvPicPr>
-          <p:nvPr/>
-        </p:nvPicPr>
-        <p:blipFill>
-          <a:blip r:embed="rId1"/>
-          <a:stretch>
-            <a:fillRect/>
-          </a:stretch>
-        </p:blipFill>
-        <p:spPr>
-          <a:xfrm>
-            <a:off x="457200" y="1051560"/>
-            <a:ext cx="5235828" cy="3657600"/>
-          </a:xfrm>
-          <a:prstGeom prst="rect">
-            <a:avLst/>
-          </a:prstGeom>
-          <a:effectLst>
-            <a:outerShdw sx="100000" sy="100000" kx="0" ky="0" algn="bl" rotWithShape="0" blurRad="76200" dist="25400" dir="5400000">
-              <a:srgbClr val="000000">
-                <a:alpha val="18000"/>
-              </a:srgbClr>
-            </a:outerShdw>
-          </a:effectLst>
-        </p:spPr>
-      </p:pic>
-      <p:sp>
-        <p:nvSpPr>
-          <p:cNvPr id="5" name="Text 2"/>
-          <p:cNvSpPr txBox="1"/>
-          <p:nvPr/>
-        </p:nvSpPr>
-        <p:spPr>
-          <a:xfrm>
-            <a:off x="6126480" y="1188720"/>
-            <a:ext cx="2651760" cy="3474720"/>
-          </a:xfrm>
-          <a:prstGeom prst="rect">
-            <a:avLst/>
-          </a:prstGeom>
-          <a:noFill/>
-          <a:ln/>
-        </p:spPr>
-        <p:txBody>
-          <a:bodyPr wrap="square" lIns="0" tIns="0" rIns="0" bIns="0" rtlCol="0" anchor="t"/>
-          <a:lstStyle/>
-          <a:p>
-            <a:pPr indent="0" marL="0">
-              <a:buNone/>
-            </a:pPr>
-            <a:r>
-              <a:rPr lang="en-US" sz="1400" b="1" dirty="0">
-                <a:solidFill>
-                  <a:schemeClr val="tx1"/>
-                </a:solidFill>
-              </a:rPr>
-              <a:t>Everything is prepared</a:t>
-            </a:r>
-            <a:endParaRPr lang="en-US" sz="1400" dirty="0"/>
-          </a:p>
-          <a:p>
-            <a:pPr indent="0" marL="0">
-              <a:buNone/>
-            </a:pPr>
-            <a:r>
-              <a:rPr lang="en-US" sz="1400" dirty="0">
-                <a:solidFill>
-                  <a:schemeClr val="accent2"/>
-                </a:solidFill>
-              </a:rPr>
-              <a:t>The project carries step-by-step instructions for Claude, so it knows how to guide you.</a:t>
-            </a:r>
-            <a:endParaRPr lang="en-US" sz="1400" dirty="0"/>
-          </a:p>
-          <a:p>
-            <a:pPr indent="0" marL="0">
-              <a:buNone/>
-            </a:pPr>
-            <a:r>
-              <a:rPr lang="en-US" sz="800" dirty="0">
-                <a:solidFill>
-                  <a:schemeClr val="tx1"/>
-                </a:solidFill>
-              </a:rPr>
-              <a:t> </a:t>
-            </a:r>
-            <a:endParaRPr lang="en-US" sz="1400" dirty="0"/>
-          </a:p>
-          <a:p>
-            <a:pPr indent="0" marL="0">
-              <a:buNone/>
-            </a:pPr>
-            <a:r>
-              <a:rPr lang="en-US" sz="1400" b="1" dirty="0">
-                <a:solidFill>
-                  <a:schemeClr val="tx1"/>
-                </a:solidFill>
-              </a:rPr>
-              <a:t>Click your answers</a:t>
-            </a:r>
-            <a:endParaRPr lang="en-US" sz="1400" dirty="0"/>
-          </a:p>
-          <a:p>
-            <a:pPr indent="0" marL="0">
-              <a:buNone/>
-            </a:pPr>
-            <a:r>
-              <a:rPr lang="en-US" sz="1400" dirty="0">
-                <a:solidFill>
-                  <a:schemeClr val="accent2"/>
-                </a:solidFill>
-              </a:rPr>
-              <a:t>Claude asks with buttons. Pick one, or choose Other and type your own.</a:t>
-            </a:r>
-            <a:endParaRPr lang="en-US" sz="1400" dirty="0"/>
-          </a:p>
-          <a:p>
-            <a:pPr indent="0" marL="0">
-              <a:buNone/>
-            </a:pPr>
-            <a:r>
-              <a:rPr lang="en-US" sz="800" dirty="0">
-                <a:solidFill>
-                  <a:schemeClr val="tx1"/>
-                </a:solidFill>
-              </a:rPr>
-              <a:t> </a:t>
-            </a:r>
-            <a:endParaRPr lang="en-US" sz="1400" dirty="0"/>
-          </a:p>
-          <a:p>
-            <a:pPr indent="0" marL="0">
-              <a:buNone/>
-            </a:pPr>
-            <a:r>
-              <a:rPr lang="en-US" sz="1400" b="1" dirty="0">
-                <a:solidFill>
-                  <a:schemeClr val="tx1"/>
-                </a:solidFill>
-              </a:rPr>
-              <a:t>It starts your private copy</a:t>
-            </a:r>
-            <a:endParaRPr lang="en-US" sz="1400" dirty="0"/>
-          </a:p>
-          <a:p>
-            <a:pPr indent="0" marL="0">
-              <a:buNone/>
-            </a:pPr>
-            <a:r>
-              <a:rPr lang="en-US" sz="1400" dirty="0">
-                <a:solidFill>
-                  <a:schemeClr val="accent2"/>
-                </a:solidFill>
-              </a:rPr>
-              <a:t>And tells you where to open it.</a:t>
-            </a:r>
-            <a:endParaRPr lang="en-US" sz="1400" dirty="0"/>
-          </a:p>
-        </p:txBody>
-      </p:sp>
-      <p:sp>
-        <p:nvSpPr>
-          <p:cNvPr id="25" name="Slide Number Placeholder 0"/>
-          <p:cNvSpPr>
-            <a:spLocks noGrp="1"/>
-          </p:cNvSpPr>
-          <p:nvPr>
-            <p:ph type="sldNum" sz="quarter" idx="4294967295"/>
-          </p:nvPr>
-        </p:nvSpPr>
-        <p:spPr>
-          <a:xfrm>
-            <a:off x="8503920" y="4754880"/>
-            <a:ext cx="365760" cy="274320"/>
-          </a:xfrm>
-          <a:prstGeom prst="rect">
-            <a:avLst/>
-          </a:prstGeom>
-          <a:extLst>
-            <a:ext uri="{C572A759-6A51-4108-AA02-DFA0A04FC94B}">
-              <ma14:wrappingTextBoxFlag xmlns:ma14="http://schemas.microsoft.com/office/mac/drawingml/2011/main" val="0"/>
-            </a:ext>
-          </a:extLst>
-        </p:spPr>
-        <p:txBody>
-          <a:bodyPr/>
-          <a:lstStyle>
-            <a:lvl1pPr>
-              <a:defRPr sz="1000">
-                <a:solidFill>
-                  <a:schemeClr val="accent3"/>
-                </a:solidFill>
-              </a:defRPr>
-            </a:lvl1pPr>
-          </a:lstStyle>
-          <a:p>
-            <a:pPr algn="l"/>
-            <a:fld id="{F7021451-1387-4CA6-816F-3879F97B5CBC}" type="slidenum">
-              <a:rPr b="0" lang="en-US"/>
-              <a:t>11</a:t>
             </a:fld>
             <a:endParaRPr lang="en-US"/>
           </a:p>
@@ -3963,8 +3663,8 @@
         </p:nvSpPr>
         <p:spPr>
           <a:xfrm>
-            <a:off x="777240" y="1115568"/>
-            <a:ext cx="2194560" cy="411480"/>
+            <a:off x="731520" y="1115568"/>
+            <a:ext cx="1645920" cy="411480"/>
           </a:xfrm>
           <a:prstGeom prst="rect">
             <a:avLst/>
@@ -3985,7 +3685,7 @@
                   <a:schemeClr val="tx1"/>
                 </a:solidFill>
               </a:rPr>
-              <a:t>Smallest and largest sizes</a:t>
+              <a:t>Smallest and largest</a:t>
             </a:r>
             <a:endParaRPr lang="en-US" sz="1400" dirty="0"/>
           </a:p>
@@ -3999,7 +3699,7 @@
         </p:nvSpPr>
         <p:spPr>
           <a:xfrm>
-            <a:off x="3017520" y="1097280"/>
+            <a:off x="2468880" y="1097280"/>
             <a:ext cx="274320" cy="365760"/>
           </a:xfrm>
           <a:prstGeom prst="rect">
@@ -4035,8 +3735,8 @@
         </p:nvSpPr>
         <p:spPr>
           <a:xfrm>
-            <a:off x="3337560" y="1115568"/>
-            <a:ext cx="2194560" cy="411480"/>
+            <a:off x="2788920" y="1115568"/>
+            <a:ext cx="1645920" cy="411480"/>
           </a:xfrm>
           <a:prstGeom prst="rect">
             <a:avLst/>
@@ -4107,8 +3807,8 @@
         </p:nvSpPr>
         <p:spPr>
           <a:xfrm>
-            <a:off x="777240" y="1664208"/>
-            <a:ext cx="2194560" cy="411480"/>
+            <a:off x="731520" y="1664208"/>
+            <a:ext cx="1645920" cy="411480"/>
           </a:xfrm>
           <a:prstGeom prst="rect">
             <a:avLst/>
@@ -4129,7 +3829,7 @@
                   <a:schemeClr val="tx1"/>
                 </a:solidFill>
               </a:rPr>
-              <a:t>Make each warning appear</a:t>
+              <a:t>Trigger each warning</a:t>
             </a:r>
             <a:endParaRPr lang="en-US" sz="1400" dirty="0"/>
           </a:p>
@@ -4143,7 +3843,7 @@
         </p:nvSpPr>
         <p:spPr>
           <a:xfrm>
-            <a:off x="3017520" y="1645920"/>
+            <a:off x="2468880" y="1645920"/>
             <a:ext cx="274320" cy="365760"/>
           </a:xfrm>
           <a:prstGeom prst="rect">
@@ -4179,8 +3879,8 @@
         </p:nvSpPr>
         <p:spPr>
           <a:xfrm>
-            <a:off x="3337560" y="1664208"/>
-            <a:ext cx="2194560" cy="411480"/>
+            <a:off x="2788920" y="1664208"/>
+            <a:ext cx="1645920" cy="411480"/>
           </a:xfrm>
           <a:prstGeom prst="rect">
             <a:avLst/>
@@ -4201,7 +3901,7 @@
                   <a:schemeClr val="tx1"/>
                 </a:solidFill>
               </a:rPr>
-              <a:t>Click parts in the 3D view</a:t>
+              <a:t>Click parts in 3D</a:t>
             </a:r>
             <a:endParaRPr lang="en-US" sz="1400" dirty="0"/>
           </a:p>
@@ -4251,8 +3951,8 @@
         </p:nvSpPr>
         <p:spPr>
           <a:xfrm>
-            <a:off x="777240" y="2212848"/>
-            <a:ext cx="2194560" cy="411480"/>
+            <a:off x="731520" y="2212848"/>
+            <a:ext cx="1645920" cy="411480"/>
           </a:xfrm>
           <a:prstGeom prst="rect">
             <a:avLst/>
@@ -4273,7 +3973,7 @@
                   <a:schemeClr val="tx1"/>
                 </a:solidFill>
               </a:rPr>
-              <a:t>Find it in the top menu</a:t>
+              <a:t>Find it in the menu</a:t>
             </a:r>
             <a:endParaRPr lang="en-US" sz="1400" dirty="0"/>
           </a:p>
@@ -4287,7 +3987,7 @@
         </p:nvSpPr>
         <p:spPr>
           <a:xfrm>
-            <a:off x="3017520" y="2194560"/>
+            <a:off x="2468880" y="2194560"/>
             <a:ext cx="274320" cy="365760"/>
           </a:xfrm>
           <a:prstGeom prst="rect">
@@ -4323,8 +4023,8 @@
         </p:nvSpPr>
         <p:spPr>
           <a:xfrm>
-            <a:off x="3337560" y="2212848"/>
-            <a:ext cx="2194560" cy="411480"/>
+            <a:off x="2788920" y="2212848"/>
+            <a:ext cx="1645920" cy="411480"/>
           </a:xfrm>
           <a:prstGeom prst="rect">
             <a:avLst/>
@@ -4345,7 +4045,7 @@
                   <a:schemeClr val="tx1"/>
                 </a:solidFill>
               </a:rPr>
-              <a:t>Download and read the PDF</a:t>
+              <a:t>Read the PDF</a:t>
             </a:r>
             <a:endParaRPr lang="en-US" sz="1400" dirty="0"/>
           </a:p>
@@ -4395,8 +4095,8 @@
         </p:nvSpPr>
         <p:spPr>
           <a:xfrm>
-            <a:off x="777240" y="2761488"/>
-            <a:ext cx="2194560" cy="411480"/>
+            <a:off x="731520" y="2761488"/>
+            <a:ext cx="1645920" cy="411480"/>
           </a:xfrm>
           <a:prstGeom prst="rect">
             <a:avLst/>
@@ -4417,7 +4117,7 @@
                   <a:schemeClr val="tx1"/>
                 </a:solidFill>
               </a:rPr>
-              <a:t>Shelf and desk still work</a:t>
+              <a:t>Shelf and desk work</a:t>
             </a:r>
             <a:endParaRPr lang="en-US" sz="1400" dirty="0"/>
           </a:p>
@@ -4431,7 +4131,7 @@
         </p:nvSpPr>
         <p:spPr>
           <a:xfrm>
-            <a:off x="3017520" y="2743200"/>
+            <a:off x="2468880" y="2743200"/>
             <a:ext cx="274320" cy="365760"/>
           </a:xfrm>
           <a:prstGeom prst="rect">
@@ -4467,8 +4167,8 @@
         </p:nvSpPr>
         <p:spPr>
           <a:xfrm>
-            <a:off x="3337560" y="2761488"/>
-            <a:ext cx="2194560" cy="411480"/>
+            <a:off x="2788920" y="2761488"/>
+            <a:ext cx="1645920" cy="411480"/>
           </a:xfrm>
           <a:prstGeom prst="rect">
             <a:avLst/>
@@ -4489,7 +4189,7 @@
                   <a:schemeClr val="tx1"/>
                 </a:solidFill>
               </a:rPr>
-              <a:t>Narrow window, like a phone</a:t>
+              <a:t>Phone-width window</a:t>
             </a:r>
             <a:endParaRPr lang="en-US" sz="1400" dirty="0"/>
           </a:p>
@@ -4503,8 +4203,8 @@
         </p:nvSpPr>
         <p:spPr>
           <a:xfrm>
-            <a:off x="457200" y="3383280"/>
-            <a:ext cx="5029200" cy="1188720"/>
+            <a:off x="457200" y="3291840"/>
+            <a:ext cx="3931920" cy="1371600"/>
           </a:xfrm>
           <a:prstGeom prst="roundRect">
             <a:avLst>
@@ -4530,8 +4230,8 @@
         </p:nvSpPr>
         <p:spPr>
           <a:xfrm>
-            <a:off x="640080" y="3493008"/>
-            <a:ext cx="4663440" cy="1005840"/>
+            <a:off x="594360" y="3383280"/>
+            <a:ext cx="3566160" cy="1188720"/>
           </a:xfrm>
           <a:prstGeom prst="rect">
             <a:avLst/>
@@ -4613,8 +4313,8 @@
         </p:blipFill>
         <p:spPr>
           <a:xfrm>
-            <a:off x="5577840" y="1097280"/>
-            <a:ext cx="3291840" cy="1958645"/>
+            <a:off x="4617720" y="1097280"/>
+            <a:ext cx="4251960" cy="2529916"/>
           </a:xfrm>
           <a:prstGeom prst="rect">
             <a:avLst/>
@@ -4636,8 +4336,8 @@
         </p:nvSpPr>
         <p:spPr>
           <a:xfrm>
-            <a:off x="5577840" y="3147365"/>
-            <a:ext cx="3291840" cy="457200"/>
+            <a:off x="4617720" y="3718636"/>
+            <a:ext cx="4251960" cy="320040"/>
           </a:xfrm>
           <a:prstGeom prst="rect">
             <a:avLst/>
@@ -4942,47 +4642,19 @@
       </p:sp>
       <p:sp>
         <p:nvSpPr>
-          <p:cNvPr id="7" name="Shape 4"/>
-          <p:cNvSpPr/>
+          <p:cNvPr id="40" name="Real PR link"/>
+          <p:cNvSpPr txBox="1"/>
           <p:nvPr/>
         </p:nvSpPr>
         <p:spPr>
           <a:xfrm>
             <a:off x="4937760" y="3977640"/>
-            <a:ext cx="3840480" cy="731520"/>
-          </a:xfrm>
-          <a:prstGeom prst="roundRect">
-            <a:avLst>
-              <a:gd name="adj" fmla="val 5000"/>
-            </a:avLst>
-          </a:prstGeom>
-          <a:solidFill>
-            <a:schemeClr val="bg2"/>
-          </a:solidFill>
-          <a:ln w="9525">
-            <a:solidFill>
-              <a:schemeClr val="accent4"/>
-            </a:solidFill>
-            <a:prstDash val="solid"/>
-          </a:ln>
-        </p:spPr>
-      </p:sp>
-      <p:sp>
-        <p:nvSpPr>
-          <p:cNvPr id="8" name="Text 5"/>
-          <p:cNvSpPr txBox="1"/>
-          <p:nvPr/>
-        </p:nvSpPr>
-        <p:spPr>
-          <a:xfrm>
-            <a:off x="5120640" y="4069080"/>
-            <a:ext cx="3474720" cy="548640"/>
+            <a:ext cx="3840480" cy="640080"/>
           </a:xfrm>
           <a:prstGeom prst="rect">
             <a:avLst/>
           </a:prstGeom>
           <a:noFill/>
-          <a:ln/>
         </p:spPr>
         <p:txBody>
           <a:bodyPr wrap="square" lIns="0" tIns="0" rIns="0" bIns="0" rtlCol="0" anchor="t"/>
@@ -4992,14 +4664,19 @@
               <a:buNone/>
             </a:pPr>
             <a:r>
+              <a:rPr lang="en-US" sz="1300" b="1" dirty="0">
+                <a:solidFill>
+                  <a:schemeClr val="tx1"/>
+                </a:solidFill>
+              </a:rPr>
+              <a:t>See a real pull request: </a:t>
+            </a:r>
+            <a:r>
               <a:rPr lang="en-US" sz="1300" dirty="0">
-                <a:solidFill>
-                  <a:schemeClr val="tx1"/>
-                </a:solidFill>
-              </a:rPr>
-              <a:t>Your one job: drag the screenshots into it on GitHub.</a:t>
-            </a:r>
-            <a:endParaRPr lang="en-US" sz="1300" dirty="0"/>
+                <a:hlinkClick r:id="rId900"/>
+              </a:rPr>
+              <a:t>github.com/mfprado/open-source-modular-furniture/pull/10</a:t>
+            </a:r>
           </a:p>
         </p:txBody>
       </p:sp>
@@ -5885,7 +5562,30 @@
                 <a:ea typeface="Courier New" pitchFamily="34" charset="-122"/>
                 <a:cs typeface="Courier New" pitchFamily="34" charset="-120"/>
               </a:rPr>
-              <a:t>"I want to work on github.com/mfprado/open-source-modular-furniture. Clone it and let's start"</a:t>
+              <a:t>"I want to work on </a:t>
+            </a:r>
+            <a:r>
+              <a:rPr lang="en-US" sz="1200" dirty="0">
+                <a:solidFill>
+                  <a:schemeClr val="bg1"/>
+                </a:solidFill>
+                <a:latin typeface="Courier New" pitchFamily="34" charset="0"/>
+                <a:ea typeface="Courier New" pitchFamily="34" charset="-122"/>
+                <a:cs typeface="Courier New" pitchFamily="34" charset="-120"/>
+                <a:hlinkClick r:id="rId900"/>
+              </a:rPr>
+              <a:t>github.com/mfprado/open-source-modular-furniture</a:t>
+            </a:r>
+            <a:r>
+              <a:rPr lang="en-US" sz="1200" dirty="0">
+                <a:solidFill>
+                  <a:schemeClr val="bg1"/>
+                </a:solidFill>
+                <a:latin typeface="Courier New" pitchFamily="34" charset="0"/>
+                <a:ea typeface="Courier New" pitchFamily="34" charset="-122"/>
+                <a:cs typeface="Courier New" pitchFamily="34" charset="-120"/>
+              </a:rPr>
+              <a:t>. Clone it and let's start"</a:t>
             </a:r>
             <a:endParaRPr lang="en-US" sz="1200" dirty="0"/>
           </a:p>
@@ -6934,7 +6634,24 @@
                   <a:schemeClr val="accent2"/>
                 </a:solidFill>
               </a:rPr>
-              <a:t>Free, at github.com/signup. GitHub is where the project lives.</a:t>
+              <a:t>Free, at </a:t>
+            </a:r>
+            <a:r>
+              <a:rPr lang="en-US" sz="1400" dirty="0">
+                <a:solidFill>
+                  <a:schemeClr val="accent2"/>
+                </a:solidFill>
+                <a:hlinkClick r:id="rId900"/>
+              </a:rPr>
+              <a:t>github.com/signup</a:t>
+            </a:r>
+            <a:r>
+              <a:rPr lang="en-US" sz="1400" dirty="0">
+                <a:solidFill>
+                  <a:schemeClr val="accent2"/>
+                </a:solidFill>
+              </a:rPr>
+              <a:t>. GitHub is where the project lives.</a:t>
             </a:r>
             <a:endParaRPr lang="en-US" sz="1400" dirty="0"/>
           </a:p>
@@ -7049,7 +6766,24 @@
                   <a:schemeClr val="accent2"/>
                 </a:solidFill>
               </a:rPr>
-              <a:t>Download it from claude.ai/download, install it and sign in.</a:t>
+              <a:t>Download it from </a:t>
+            </a:r>
+            <a:r>
+              <a:rPr lang="en-US" sz="1400" dirty="0">
+                <a:solidFill>
+                  <a:schemeClr val="accent2"/>
+                </a:solidFill>
+                <a:hlinkClick r:id="rId901"/>
+              </a:rPr>
+              <a:t>claude.ai/download</a:t>
+            </a:r>
+            <a:r>
+              <a:rPr lang="en-US" sz="1400" dirty="0">
+                <a:solidFill>
+                  <a:schemeClr val="accent2"/>
+                </a:solidFill>
+              </a:rPr>
+              <a:t>, install it and sign in.</a:t>
             </a:r>
             <a:endParaRPr lang="en-US" sz="1400" dirty="0"/>
           </a:p>

</xml_diff>